<commit_message>
improved schematic for contingency table
</commit_message>
<xml_diff>
--- a/chapter_05/figures/contingency_table_prob_fc.pptx
+++ b/chapter_05/figures/contingency_table_prob_fc.pptx
@@ -2,12 +2,12 @@
 <file path=ppt/presentation.xml><?xml version="1.0" encoding="utf-8"?>
 <p:presentation xmlns:a="http://schemas.openxmlformats.org/drawingml/2006/main" xmlns:r="http://schemas.openxmlformats.org/officeDocument/2006/relationships" xmlns:p="http://schemas.openxmlformats.org/presentationml/2006/main" saveSubsetFonts="1">
   <p:sldMasterIdLst>
-    <p:sldMasterId id="2147483780" r:id="rId1"/>
+    <p:sldMasterId id="2147483804" r:id="rId1"/>
   </p:sldMasterIdLst>
   <p:sldIdLst>
     <p:sldId id="256" r:id="rId2"/>
   </p:sldIdLst>
-  <p:sldSz cx="5759450" cy="2519363"/>
+  <p:sldSz cx="5759450" cy="4427538"/>
   <p:notesSz cx="6858000" cy="9144000"/>
   <p:defaultTextStyle>
     <a:defPPr>
@@ -115,7 +115,7 @@
 <file path=ppt/revisionInfo.xml><?xml version="1.0" encoding="utf-8"?>
 <p1510:revInfo xmlns:a="http://schemas.openxmlformats.org/drawingml/2006/main" xmlns:r="http://schemas.openxmlformats.org/officeDocument/2006/relationships" xmlns:p1510="http://schemas.microsoft.com/office/powerpoint/2015/10/main">
   <p1510:revLst>
-    <p1510:client id="{8AA7C05A-A40B-47BE-AD88-53F73456539F}" v="16" dt="2026-01-22T23:34:23.477"/>
+    <p1510:client id="{8AA7C05A-A40B-47BE-AD88-53F73456539F}" v="32" dt="2026-01-23T00:37:55.151"/>
   </p1510:revLst>
 </p1510:revInfo>
 </file>
@@ -125,12 +125,12 @@
   <pc:docChgLst>
     <pc:chgData name="Fatima Pillosu" userId="a6295d4dc9e22643" providerId="LiveId" clId="{87453732-75AC-4426-B5D3-B7C69C2D4F54}"/>
     <pc:docChg chg="undo custSel modSld">
-      <pc:chgData name="Fatima Pillosu" userId="a6295d4dc9e22643" providerId="LiveId" clId="{87453732-75AC-4426-B5D3-B7C69C2D4F54}" dt="2026-01-22T23:34:52.514" v="1178" actId="1036"/>
+      <pc:chgData name="Fatima Pillosu" userId="a6295d4dc9e22643" providerId="LiveId" clId="{87453732-75AC-4426-B5D3-B7C69C2D4F54}" dt="2026-01-23T00:38:00.791" v="1786" actId="1035"/>
       <pc:docMkLst>
         <pc:docMk/>
       </pc:docMkLst>
       <pc:sldChg chg="addSp delSp modSp mod">
-        <pc:chgData name="Fatima Pillosu" userId="a6295d4dc9e22643" providerId="LiveId" clId="{87453732-75AC-4426-B5D3-B7C69C2D4F54}" dt="2026-01-22T23:34:52.514" v="1178" actId="1036"/>
+        <pc:chgData name="Fatima Pillosu" userId="a6295d4dc9e22643" providerId="LiveId" clId="{87453732-75AC-4426-B5D3-B7C69C2D4F54}" dt="2026-01-23T00:38:00.791" v="1786" actId="1035"/>
         <pc:sldMkLst>
           <pc:docMk/>
           <pc:sldMk cId="1573992039" sldId="256"/>
@@ -141,6 +141,14 @@
             <pc:docMk/>
             <pc:sldMk cId="1573992039" sldId="256"/>
             <ac:spMk id="2" creationId="{34FB978C-5A46-EB58-15FD-D1D6FE42766B}"/>
+          </ac:spMkLst>
+        </pc:spChg>
+        <pc:spChg chg="add mod">
+          <ac:chgData name="Fatima Pillosu" userId="a6295d4dc9e22643" providerId="LiveId" clId="{87453732-75AC-4426-B5D3-B7C69C2D4F54}" dt="2026-01-23T00:20:11.463" v="1180"/>
+          <ac:spMkLst>
+            <pc:docMk/>
+            <pc:sldMk cId="1573992039" sldId="256"/>
+            <ac:spMk id="2" creationId="{863D7830-3EC5-1488-4779-4B842624939D}"/>
           </ac:spMkLst>
         </pc:spChg>
         <pc:spChg chg="add del mod">
@@ -159,12 +167,28 @@
             <ac:spMk id="4" creationId="{863D7830-3EC5-1488-4779-4B842624939D}"/>
           </ac:spMkLst>
         </pc:spChg>
+        <pc:spChg chg="mod">
+          <ac:chgData name="Fatima Pillosu" userId="a6295d4dc9e22643" providerId="LiveId" clId="{87453732-75AC-4426-B5D3-B7C69C2D4F54}" dt="2026-01-23T00:28:33.856" v="1263" actId="207"/>
+          <ac:spMkLst>
+            <pc:docMk/>
+            <pc:sldMk cId="1573992039" sldId="256"/>
+            <ac:spMk id="8" creationId="{ADEEF2B1-EBC8-9F1F-6B1F-DD1E6A4ADDB0}"/>
+          </ac:spMkLst>
+        </pc:spChg>
         <pc:spChg chg="add del mod">
           <ac:chgData name="Fatima Pillosu" userId="a6295d4dc9e22643" providerId="LiveId" clId="{87453732-75AC-4426-B5D3-B7C69C2D4F54}" dt="2026-01-22T23:34:11.915" v="1169" actId="21"/>
           <ac:spMkLst>
             <pc:docMk/>
             <pc:sldMk cId="1573992039" sldId="256"/>
             <ac:spMk id="9" creationId="{ADEEF2B1-EBC8-9F1F-6B1F-DD1E6A4ADDB0}"/>
+          </ac:spMkLst>
+        </pc:spChg>
+        <pc:spChg chg="add del mod">
+          <ac:chgData name="Fatima Pillosu" userId="a6295d4dc9e22643" providerId="LiveId" clId="{87453732-75AC-4426-B5D3-B7C69C2D4F54}" dt="2026-01-23T00:37:43.961" v="1781" actId="21"/>
+          <ac:spMkLst>
+            <pc:docMk/>
+            <pc:sldMk cId="1573992039" sldId="256"/>
+            <ac:spMk id="9" creationId="{CDB02FB9-7686-55B5-2237-CE34FE7138F4}"/>
           </ac:spMkLst>
         </pc:spChg>
         <pc:spChg chg="add mod">
@@ -199,6 +223,14 @@
             <ac:spMk id="15" creationId="{31526C8F-65EA-4AE2-A6F7-E27D64A802EA}"/>
           </ac:spMkLst>
         </pc:spChg>
+        <pc:spChg chg="del">
+          <ac:chgData name="Fatima Pillosu" userId="a6295d4dc9e22643" providerId="LiveId" clId="{87453732-75AC-4426-B5D3-B7C69C2D4F54}" dt="2026-01-23T00:37:43.961" v="1781" actId="21"/>
+          <ac:spMkLst>
+            <pc:docMk/>
+            <pc:sldMk cId="1573992039" sldId="256"/>
+            <ac:spMk id="15" creationId="{871F6875-B35B-38C5-3426-33D516CADAB5}"/>
+          </ac:spMkLst>
+        </pc:spChg>
         <pc:spChg chg="add del mod">
           <ac:chgData name="Fatima Pillosu" userId="a6295d4dc9e22643" providerId="LiveId" clId="{87453732-75AC-4426-B5D3-B7C69C2D4F54}" dt="2026-01-22T22:57:57.325" v="214" actId="21"/>
           <ac:spMkLst>
@@ -208,11 +240,27 @@
           </ac:spMkLst>
         </pc:spChg>
         <pc:spChg chg="del">
+          <ac:chgData name="Fatima Pillosu" userId="a6295d4dc9e22643" providerId="LiveId" clId="{87453732-75AC-4426-B5D3-B7C69C2D4F54}" dt="2026-01-23T00:37:43.961" v="1781" actId="21"/>
+          <ac:spMkLst>
+            <pc:docMk/>
+            <pc:sldMk cId="1573992039" sldId="256"/>
+            <ac:spMk id="17" creationId="{1ACBC9A4-96CE-2145-4C13-43843EED1EEE}"/>
+          </ac:spMkLst>
+        </pc:spChg>
+        <pc:spChg chg="del">
           <ac:chgData name="Fatima Pillosu" userId="a6295d4dc9e22643" providerId="LiveId" clId="{87453732-75AC-4426-B5D3-B7C69C2D4F54}" dt="2026-01-22T22:57:57.325" v="214" actId="21"/>
           <ac:spMkLst>
             <pc:docMk/>
             <pc:sldMk cId="1573992039" sldId="256"/>
             <ac:spMk id="17" creationId="{CDB02FB9-7686-55B5-2237-CE34FE7138F4}"/>
+          </ac:spMkLst>
+        </pc:spChg>
+        <pc:spChg chg="del">
+          <ac:chgData name="Fatima Pillosu" userId="a6295d4dc9e22643" providerId="LiveId" clId="{87453732-75AC-4426-B5D3-B7C69C2D4F54}" dt="2026-01-23T00:37:43.961" v="1781" actId="21"/>
+          <ac:spMkLst>
+            <pc:docMk/>
+            <pc:sldMk cId="1573992039" sldId="256"/>
+            <ac:spMk id="18" creationId="{5CCEEB50-0EB3-291D-2911-B86403C69D4E}"/>
           </ac:spMkLst>
         </pc:spChg>
         <pc:spChg chg="mod topLvl">
@@ -271,12 +319,28 @@
             <ac:spMk id="25" creationId="{A09387BF-360E-1373-B4E2-484CDF5B6943}"/>
           </ac:spMkLst>
         </pc:spChg>
+        <pc:spChg chg="add del mod">
+          <ac:chgData name="Fatima Pillosu" userId="a6295d4dc9e22643" providerId="LiveId" clId="{87453732-75AC-4426-B5D3-B7C69C2D4F54}" dt="2026-01-23T00:37:43.961" v="1781" actId="21"/>
+          <ac:spMkLst>
+            <pc:docMk/>
+            <pc:sldMk cId="1573992039" sldId="256"/>
+            <ac:spMk id="25" creationId="{F3106249-1C45-1C12-2453-07133FF1CD86}"/>
+          </ac:spMkLst>
+        </pc:spChg>
         <pc:spChg chg="mod">
           <ac:chgData name="Fatima Pillosu" userId="a6295d4dc9e22643" providerId="LiveId" clId="{87453732-75AC-4426-B5D3-B7C69C2D4F54}" dt="2026-01-22T22:56:44.430" v="208" actId="164"/>
           <ac:spMkLst>
             <pc:docMk/>
             <pc:sldMk cId="1573992039" sldId="256"/>
             <ac:spMk id="26" creationId="{E1F6673A-1B0C-E424-8F99-86B139BD4918}"/>
+          </ac:spMkLst>
+        </pc:spChg>
+        <pc:spChg chg="add del mod">
+          <ac:chgData name="Fatima Pillosu" userId="a6295d4dc9e22643" providerId="LiveId" clId="{87453732-75AC-4426-B5D3-B7C69C2D4F54}" dt="2026-01-23T00:37:43.961" v="1781" actId="21"/>
+          <ac:spMkLst>
+            <pc:docMk/>
+            <pc:sldMk cId="1573992039" sldId="256"/>
+            <ac:spMk id="27" creationId="{2D87FE8A-4BD4-D2C0-4981-4C00E52C4C21}"/>
           </ac:spMkLst>
         </pc:spChg>
         <pc:spChg chg="mod">
@@ -312,11 +376,35 @@
           </ac:spMkLst>
         </pc:spChg>
         <pc:spChg chg="mod">
+          <ac:chgData name="Fatima Pillosu" userId="a6295d4dc9e22643" providerId="LiveId" clId="{87453732-75AC-4426-B5D3-B7C69C2D4F54}" dt="2026-01-23T00:29:24.574" v="1272" actId="207"/>
+          <ac:spMkLst>
+            <pc:docMk/>
+            <pc:sldMk cId="1573992039" sldId="256"/>
+            <ac:spMk id="30" creationId="{4ABA71F5-F7CE-E653-5451-1F27E1EA51A4}"/>
+          </ac:spMkLst>
+        </pc:spChg>
+        <pc:spChg chg="mod">
           <ac:chgData name="Fatima Pillosu" userId="a6295d4dc9e22643" providerId="LiveId" clId="{87453732-75AC-4426-B5D3-B7C69C2D4F54}" dt="2026-01-22T22:57:26.135" v="211" actId="164"/>
           <ac:spMkLst>
             <pc:docMk/>
             <pc:sldMk cId="1573992039" sldId="256"/>
             <ac:spMk id="31" creationId="{5CCEEB50-0EB3-291D-2911-B86403C69D4E}"/>
+          </ac:spMkLst>
+        </pc:spChg>
+        <pc:spChg chg="del">
+          <ac:chgData name="Fatima Pillosu" userId="a6295d4dc9e22643" providerId="LiveId" clId="{87453732-75AC-4426-B5D3-B7C69C2D4F54}" dt="2026-01-23T00:37:43.961" v="1781" actId="21"/>
+          <ac:spMkLst>
+            <pc:docMk/>
+            <pc:sldMk cId="1573992039" sldId="256"/>
+            <ac:spMk id="32" creationId="{D0B60395-29A9-5583-BABB-33B236329A61}"/>
+          </ac:spMkLst>
+        </pc:spChg>
+        <pc:spChg chg="add mod">
+          <ac:chgData name="Fatima Pillosu" userId="a6295d4dc9e22643" providerId="LiveId" clId="{87453732-75AC-4426-B5D3-B7C69C2D4F54}" dt="2026-01-23T00:20:11.463" v="1180"/>
+          <ac:spMkLst>
+            <pc:docMk/>
+            <pc:sldMk cId="1573992039" sldId="256"/>
+            <ac:spMk id="34" creationId="{4C39D33D-2B26-F2D6-F8F4-09E6518093E9}"/>
           </ac:spMkLst>
         </pc:spChg>
         <pc:spChg chg="mod">
@@ -359,6 +447,14 @@
             <ac:spMk id="37" creationId="{4C39D33D-2B26-F2D6-F8F4-09E6518093E9}"/>
           </ac:spMkLst>
         </pc:spChg>
+        <pc:spChg chg="add mod">
+          <ac:chgData name="Fatima Pillosu" userId="a6295d4dc9e22643" providerId="LiveId" clId="{87453732-75AC-4426-B5D3-B7C69C2D4F54}" dt="2026-01-23T00:20:11.463" v="1180"/>
+          <ac:spMkLst>
+            <pc:docMk/>
+            <pc:sldMk cId="1573992039" sldId="256"/>
+            <ac:spMk id="38" creationId="{2806A400-C100-A7CD-C682-9F752EF41C58}"/>
+          </ac:spMkLst>
+        </pc:spChg>
         <pc:spChg chg="del mod topLvl">
           <ac:chgData name="Fatima Pillosu" userId="a6295d4dc9e22643" providerId="LiveId" clId="{87453732-75AC-4426-B5D3-B7C69C2D4F54}" dt="2026-01-22T23:34:11.915" v="1169" actId="21"/>
           <ac:spMkLst>
@@ -391,6 +487,14 @@
             <ac:spMk id="39" creationId="{E3F5F678-30B9-E5A6-EDA8-349820A25D9E}"/>
           </ac:spMkLst>
         </pc:spChg>
+        <pc:spChg chg="add del mod">
+          <ac:chgData name="Fatima Pillosu" userId="a6295d4dc9e22643" providerId="LiveId" clId="{87453732-75AC-4426-B5D3-B7C69C2D4F54}" dt="2026-01-23T00:37:43.961" v="1781" actId="21"/>
+          <ac:spMkLst>
+            <pc:docMk/>
+            <pc:sldMk cId="1573992039" sldId="256"/>
+            <ac:spMk id="40" creationId="{1B78CC36-883D-5957-AD5C-423198EA1845}"/>
+          </ac:spMkLst>
+        </pc:spChg>
         <pc:spChg chg="mod topLvl">
           <ac:chgData name="Fatima Pillosu" userId="a6295d4dc9e22643" providerId="LiveId" clId="{87453732-75AC-4426-B5D3-B7C69C2D4F54}" dt="2026-01-22T23:33:12.635" v="1145" actId="165"/>
           <ac:spMkLst>
@@ -413,6 +517,14 @@
             <pc:docMk/>
             <pc:sldMk cId="1573992039" sldId="256"/>
             <ac:spMk id="41" creationId="{2806A400-C100-A7CD-C682-9F752EF41C58}"/>
+          </ac:spMkLst>
+        </pc:spChg>
+        <pc:spChg chg="add mod">
+          <ac:chgData name="Fatima Pillosu" userId="a6295d4dc9e22643" providerId="LiveId" clId="{87453732-75AC-4426-B5D3-B7C69C2D4F54}" dt="2026-01-23T00:20:11.463" v="1180"/>
+          <ac:spMkLst>
+            <pc:docMk/>
+            <pc:sldMk cId="1573992039" sldId="256"/>
+            <ac:spMk id="41" creationId="{E1F6673A-1B0C-E424-8F99-86B139BD4918}"/>
           </ac:spMkLst>
         </pc:spChg>
         <pc:spChg chg="del">
@@ -463,12 +575,28 @@
             <ac:spMk id="45" creationId="{7160EB10-8701-2F92-B2E3-BD9975B33EAB}"/>
           </ac:spMkLst>
         </pc:spChg>
+        <pc:spChg chg="add mod">
+          <ac:chgData name="Fatima Pillosu" userId="a6295d4dc9e22643" providerId="LiveId" clId="{87453732-75AC-4426-B5D3-B7C69C2D4F54}" dt="2026-01-23T00:20:11.463" v="1180"/>
+          <ac:spMkLst>
+            <pc:docMk/>
+            <pc:sldMk cId="1573992039" sldId="256"/>
+            <ac:spMk id="45" creationId="{BE8CA2C2-9A67-A315-55CF-D3B76C5B4ABF}"/>
+          </ac:spMkLst>
+        </pc:spChg>
         <pc:spChg chg="mod topLvl">
           <ac:chgData name="Fatima Pillosu" userId="a6295d4dc9e22643" providerId="LiveId" clId="{87453732-75AC-4426-B5D3-B7C69C2D4F54}" dt="2026-01-22T23:33:12.635" v="1145" actId="165"/>
           <ac:spMkLst>
             <pc:docMk/>
             <pc:sldMk cId="1573992039" sldId="256"/>
             <ac:spMk id="46" creationId="{C700B7F9-A72E-559F-D17A-BFCCF191350D}"/>
+          </ac:spMkLst>
+        </pc:spChg>
+        <pc:spChg chg="add del mod">
+          <ac:chgData name="Fatima Pillosu" userId="a6295d4dc9e22643" providerId="LiveId" clId="{87453732-75AC-4426-B5D3-B7C69C2D4F54}" dt="2026-01-23T00:37:43.961" v="1781" actId="21"/>
+          <ac:spMkLst>
+            <pc:docMk/>
+            <pc:sldMk cId="1573992039" sldId="256"/>
+            <ac:spMk id="47" creationId="{5E7D516C-6098-CA78-A68A-A60E91A03B8B}"/>
           </ac:spMkLst>
         </pc:spChg>
         <pc:spChg chg="del mod">
@@ -519,12 +647,28 @@
             <ac:spMk id="50" creationId="{16D7E8D5-094D-0801-2477-66BD27467E33}"/>
           </ac:spMkLst>
         </pc:spChg>
+        <pc:spChg chg="del">
+          <ac:chgData name="Fatima Pillosu" userId="a6295d4dc9e22643" providerId="LiveId" clId="{87453732-75AC-4426-B5D3-B7C69C2D4F54}" dt="2026-01-23T00:37:43.961" v="1781" actId="21"/>
+          <ac:spMkLst>
+            <pc:docMk/>
+            <pc:sldMk cId="1573992039" sldId="256"/>
+            <ac:spMk id="51" creationId="{748BB081-753E-2804-7F05-2F111730D61F}"/>
+          </ac:spMkLst>
+        </pc:spChg>
         <pc:spChg chg="mod">
           <ac:chgData name="Fatima Pillosu" userId="a6295d4dc9e22643" providerId="LiveId" clId="{87453732-75AC-4426-B5D3-B7C69C2D4F54}" dt="2026-01-22T23:32:53.972" v="1143" actId="554"/>
           <ac:spMkLst>
             <pc:docMk/>
             <pc:sldMk cId="1573992039" sldId="256"/>
             <ac:spMk id="53" creationId="{8C2CF4A1-967C-6891-8D3E-E404ED5D4E82}"/>
+          </ac:spMkLst>
+        </pc:spChg>
+        <pc:spChg chg="add mod">
+          <ac:chgData name="Fatima Pillosu" userId="a6295d4dc9e22643" providerId="LiveId" clId="{87453732-75AC-4426-B5D3-B7C69C2D4F54}" dt="2026-01-23T00:37:31.935" v="1778" actId="14100"/>
+          <ac:spMkLst>
+            <pc:docMk/>
+            <pc:sldMk cId="1573992039" sldId="256"/>
+            <ac:spMk id="53" creationId="{B9DACAD8-B9E0-E96C-4ACB-CB40C5842B50}"/>
           </ac:spMkLst>
         </pc:spChg>
         <pc:spChg chg="mod">
@@ -543,6 +687,22 @@
             <ac:spMk id="55" creationId="{863D7830-3EC5-1488-4779-4B842624939D}"/>
           </ac:spMkLst>
         </pc:spChg>
+        <pc:spChg chg="add mod">
+          <ac:chgData name="Fatima Pillosu" userId="a6295d4dc9e22643" providerId="LiveId" clId="{87453732-75AC-4426-B5D3-B7C69C2D4F54}" dt="2026-01-23T00:36:41.724" v="1701" actId="1037"/>
+          <ac:spMkLst>
+            <pc:docMk/>
+            <pc:sldMk cId="1573992039" sldId="256"/>
+            <ac:spMk id="59" creationId="{7F9A54EC-7677-98F3-A2A9-8D12ECCFFC18}"/>
+          </ac:spMkLst>
+        </pc:spChg>
+        <pc:spChg chg="add mod">
+          <ac:chgData name="Fatima Pillosu" userId="a6295d4dc9e22643" providerId="LiveId" clId="{87453732-75AC-4426-B5D3-B7C69C2D4F54}" dt="2026-01-23T00:36:30.315" v="1686" actId="1038"/>
+          <ac:spMkLst>
+            <pc:docMk/>
+            <pc:sldMk cId="1573992039" sldId="256"/>
+            <ac:spMk id="60" creationId="{69264F16-B69D-6B4B-97B4-69D4F6D781F7}"/>
+          </ac:spMkLst>
+        </pc:spChg>
         <pc:spChg chg="del">
           <ac:chgData name="Fatima Pillosu" userId="a6295d4dc9e22643" providerId="LiveId" clId="{87453732-75AC-4426-B5D3-B7C69C2D4F54}" dt="2026-01-22T23:30:47.467" v="1075" actId="21"/>
           <ac:spMkLst>
@@ -557,6 +717,22 @@
             <pc:docMk/>
             <pc:sldMk cId="1573992039" sldId="256"/>
             <ac:spMk id="61" creationId="{ADEEF2B1-EBC8-9F1F-6B1F-DD1E6A4ADDB0}"/>
+          </ac:spMkLst>
+        </pc:spChg>
+        <pc:spChg chg="add del mod">
+          <ac:chgData name="Fatima Pillosu" userId="a6295d4dc9e22643" providerId="LiveId" clId="{87453732-75AC-4426-B5D3-B7C69C2D4F54}" dt="2026-01-23T00:32:25.220" v="1469"/>
+          <ac:spMkLst>
+            <pc:docMk/>
+            <pc:sldMk cId="1573992039" sldId="256"/>
+            <ac:spMk id="61" creationId="{F5EC5E94-7B9D-1D9C-809B-B2AFC4F6F305}"/>
+          </ac:spMkLst>
+        </pc:spChg>
+        <pc:spChg chg="add mod">
+          <ac:chgData name="Fatima Pillosu" userId="a6295d4dc9e22643" providerId="LiveId" clId="{87453732-75AC-4426-B5D3-B7C69C2D4F54}" dt="2026-01-23T00:36:37.550" v="1689" actId="1038"/>
+          <ac:spMkLst>
+            <pc:docMk/>
+            <pc:sldMk cId="1573992039" sldId="256"/>
+            <ac:spMk id="62" creationId="{7B459E9B-BC54-D128-00BB-242594E7828F}"/>
           </ac:spMkLst>
         </pc:spChg>
         <pc:spChg chg="del mod">
@@ -575,6 +751,14 @@
             <ac:spMk id="64" creationId="{F1CE41FF-7B22-BB87-5437-9C5A6D9C40EA}"/>
           </ac:spMkLst>
         </pc:spChg>
+        <pc:spChg chg="add mod">
+          <ac:chgData name="Fatima Pillosu" userId="a6295d4dc9e22643" providerId="LiveId" clId="{87453732-75AC-4426-B5D3-B7C69C2D4F54}" dt="2026-01-23T00:36:25.910" v="1675" actId="1038"/>
+          <ac:spMkLst>
+            <pc:docMk/>
+            <pc:sldMk cId="1573992039" sldId="256"/>
+            <ac:spMk id="65" creationId="{1398DA6C-3D5E-DD45-9EEB-E8E386580228}"/>
+          </ac:spMkLst>
+        </pc:spChg>
         <pc:spChg chg="del mod">
           <ac:chgData name="Fatima Pillosu" userId="a6295d4dc9e22643" providerId="LiveId" clId="{87453732-75AC-4426-B5D3-B7C69C2D4F54}" dt="2026-01-22T23:30:47.467" v="1075" actId="21"/>
           <ac:spMkLst>
@@ -583,12 +767,28 @@
             <ac:spMk id="65" creationId="{3CDA144B-1F01-F0CC-A493-5631BE7BE96B}"/>
           </ac:spMkLst>
         </pc:spChg>
+        <pc:spChg chg="add mod">
+          <ac:chgData name="Fatima Pillosu" userId="a6295d4dc9e22643" providerId="LiveId" clId="{87453732-75AC-4426-B5D3-B7C69C2D4F54}" dt="2026-01-23T00:36:18.900" v="1661" actId="12789"/>
+          <ac:spMkLst>
+            <pc:docMk/>
+            <pc:sldMk cId="1573992039" sldId="256"/>
+            <ac:spMk id="66" creationId="{8E734807-A9EC-31E5-F187-A3C719CDF111}"/>
+          </ac:spMkLst>
+        </pc:spChg>
         <pc:spChg chg="del mod">
           <ac:chgData name="Fatima Pillosu" userId="a6295d4dc9e22643" providerId="LiveId" clId="{87453732-75AC-4426-B5D3-B7C69C2D4F54}" dt="2026-01-22T23:30:47.467" v="1075" actId="21"/>
           <ac:spMkLst>
             <pc:docMk/>
             <pc:sldMk cId="1573992039" sldId="256"/>
             <ac:spMk id="66" creationId="{9D4C28E0-97DE-3DC8-9344-F610BE62157D}"/>
+          </ac:spMkLst>
+        </pc:spChg>
+        <pc:spChg chg="add del">
+          <ac:chgData name="Fatima Pillosu" userId="a6295d4dc9e22643" providerId="LiveId" clId="{87453732-75AC-4426-B5D3-B7C69C2D4F54}" dt="2026-01-23T00:37:42.111" v="1780" actId="478"/>
+          <ac:spMkLst>
+            <pc:docMk/>
+            <pc:sldMk cId="1573992039" sldId="256"/>
+            <ac:spMk id="67" creationId="{60494B35-9ED6-E052-6C41-849A1F811BF5}"/>
           </ac:spMkLst>
         </pc:spChg>
         <pc:spChg chg="mod">
@@ -613,6 +813,22 @@
             <pc:docMk/>
             <pc:sldMk cId="1573992039" sldId="256"/>
             <ac:spMk id="76" creationId="{CDF5D99F-239B-7286-E705-43476984C1FD}"/>
+          </ac:spMkLst>
+        </pc:spChg>
+        <pc:spChg chg="add mod">
+          <ac:chgData name="Fatima Pillosu" userId="a6295d4dc9e22643" providerId="LiveId" clId="{87453732-75AC-4426-B5D3-B7C69C2D4F54}" dt="2026-01-23T00:37:55.151" v="1782"/>
+          <ac:spMkLst>
+            <pc:docMk/>
+            <pc:sldMk cId="1573992039" sldId="256"/>
+            <ac:spMk id="78" creationId="{F1CE41FF-7B22-BB87-5437-9C5A6D9C40EA}"/>
+          </ac:spMkLst>
+        </pc:spChg>
+        <pc:spChg chg="add mod">
+          <ac:chgData name="Fatima Pillosu" userId="a6295d4dc9e22643" providerId="LiveId" clId="{87453732-75AC-4426-B5D3-B7C69C2D4F54}" dt="2026-01-23T00:37:55.151" v="1782"/>
+          <ac:spMkLst>
+            <pc:docMk/>
+            <pc:sldMk cId="1573992039" sldId="256"/>
+            <ac:spMk id="79" creationId="{3CDA144B-1F01-F0CC-A493-5631BE7BE96B}"/>
           </ac:spMkLst>
         </pc:spChg>
         <pc:spChg chg="del mod">
@@ -655,6 +871,14 @@
             <ac:spMk id="90" creationId="{88FD4609-03C7-48B1-EA84-375FFFEDBE06}"/>
           </ac:spMkLst>
         </pc:spChg>
+        <pc:spChg chg="add mod">
+          <ac:chgData name="Fatima Pillosu" userId="a6295d4dc9e22643" providerId="LiveId" clId="{87453732-75AC-4426-B5D3-B7C69C2D4F54}" dt="2026-01-23T00:37:55.151" v="1782"/>
+          <ac:spMkLst>
+            <pc:docMk/>
+            <pc:sldMk cId="1573992039" sldId="256"/>
+            <ac:spMk id="91" creationId="{FEE84F7D-562E-3E17-3F19-517232627412}"/>
+          </ac:spMkLst>
+        </pc:spChg>
         <pc:spChg chg="mod">
           <ac:chgData name="Fatima Pillosu" userId="a6295d4dc9e22643" providerId="LiveId" clId="{87453732-75AC-4426-B5D3-B7C69C2D4F54}" dt="2026-01-22T22:58:11.774" v="215"/>
           <ac:spMkLst>
@@ -679,12 +903,44 @@
             <ac:spMk id="95" creationId="{2806A400-C100-A7CD-C682-9F752EF41C58}"/>
           </ac:spMkLst>
         </pc:spChg>
+        <pc:spChg chg="add mod">
+          <ac:chgData name="Fatima Pillosu" userId="a6295d4dc9e22643" providerId="LiveId" clId="{87453732-75AC-4426-B5D3-B7C69C2D4F54}" dt="2026-01-23T00:37:55.151" v="1782"/>
+          <ac:spMkLst>
+            <pc:docMk/>
+            <pc:sldMk cId="1573992039" sldId="256"/>
+            <ac:spMk id="95" creationId="{65533EAA-5F83-EA70-6747-5F625123CB00}"/>
+          </ac:spMkLst>
+        </pc:spChg>
+        <pc:spChg chg="add mod">
+          <ac:chgData name="Fatima Pillosu" userId="a6295d4dc9e22643" providerId="LiveId" clId="{87453732-75AC-4426-B5D3-B7C69C2D4F54}" dt="2026-01-23T00:37:55.151" v="1782"/>
+          <ac:spMkLst>
+            <pc:docMk/>
+            <pc:sldMk cId="1573992039" sldId="256"/>
+            <ac:spMk id="99" creationId="{88FD4609-03C7-48B1-EA84-375FFFEDBE06}"/>
+          </ac:spMkLst>
+        </pc:spChg>
+        <pc:spChg chg="add mod">
+          <ac:chgData name="Fatima Pillosu" userId="a6295d4dc9e22643" providerId="LiveId" clId="{87453732-75AC-4426-B5D3-B7C69C2D4F54}" dt="2026-01-23T00:37:55.151" v="1782"/>
+          <ac:spMkLst>
+            <pc:docMk/>
+            <pc:sldMk cId="1573992039" sldId="256"/>
+            <ac:spMk id="104" creationId="{2806A400-C100-A7CD-C682-9F752EF41C58}"/>
+          </ac:spMkLst>
+        </pc:spChg>
         <pc:spChg chg="mod">
           <ac:chgData name="Fatima Pillosu" userId="a6295d4dc9e22643" providerId="LiveId" clId="{87453732-75AC-4426-B5D3-B7C69C2D4F54}" dt="2026-01-22T23:14:40.498" v="1030" actId="1036"/>
           <ac:spMkLst>
             <pc:docMk/>
             <pc:sldMk cId="1573992039" sldId="256"/>
             <ac:spMk id="104" creationId="{5E7D516C-6098-CA78-A68A-A60E91A03B8B}"/>
+          </ac:spMkLst>
+        </pc:spChg>
+        <pc:spChg chg="add mod">
+          <ac:chgData name="Fatima Pillosu" userId="a6295d4dc9e22643" providerId="LiveId" clId="{87453732-75AC-4426-B5D3-B7C69C2D4F54}" dt="2026-01-23T00:37:55.151" v="1782"/>
+          <ac:spMkLst>
+            <pc:docMk/>
+            <pc:sldMk cId="1573992039" sldId="256"/>
+            <ac:spMk id="106" creationId="{1B78CC36-883D-5957-AD5C-423198EA1845}"/>
           </ac:spMkLst>
         </pc:spChg>
         <pc:spChg chg="add del mod">
@@ -743,12 +999,36 @@
             <ac:spMk id="124" creationId="{3CDA144B-1F01-F0CC-A493-5631BE7BE96B}"/>
           </ac:spMkLst>
         </pc:spChg>
-        <pc:spChg chg="mod">
-          <ac:chgData name="Fatima Pillosu" userId="a6295d4dc9e22643" providerId="LiveId" clId="{87453732-75AC-4426-B5D3-B7C69C2D4F54}" dt="2026-01-22T23:34:37.804" v="1174" actId="1035"/>
+        <pc:spChg chg="del">
+          <ac:chgData name="Fatima Pillosu" userId="a6295d4dc9e22643" providerId="LiveId" clId="{87453732-75AC-4426-B5D3-B7C69C2D4F54}" dt="2026-01-23T00:19:57.956" v="1179" actId="21"/>
+          <ac:spMkLst>
+            <pc:docMk/>
+            <pc:sldMk cId="1573992039" sldId="256"/>
+            <ac:spMk id="130" creationId="{5CCEEB50-0EB3-291D-2911-B86403C69D4E}"/>
+          </ac:spMkLst>
+        </pc:spChg>
+        <pc:spChg chg="del mod">
+          <ac:chgData name="Fatima Pillosu" userId="a6295d4dc9e22643" providerId="LiveId" clId="{87453732-75AC-4426-B5D3-B7C69C2D4F54}" dt="2026-01-23T00:19:57.956" v="1179" actId="21"/>
           <ac:spMkLst>
             <pc:docMk/>
             <pc:sldMk cId="1573992039" sldId="256"/>
             <ac:spMk id="133" creationId="{DD906E7D-FF64-09FE-65EF-837BDD47046A}"/>
+          </ac:spMkLst>
+        </pc:spChg>
+        <pc:spChg chg="del">
+          <ac:chgData name="Fatima Pillosu" userId="a6295d4dc9e22643" providerId="LiveId" clId="{87453732-75AC-4426-B5D3-B7C69C2D4F54}" dt="2026-01-23T00:19:57.956" v="1179" actId="21"/>
+          <ac:spMkLst>
+            <pc:docMk/>
+            <pc:sldMk cId="1573992039" sldId="256"/>
+            <ac:spMk id="137" creationId="{F3106249-1C45-1C12-2453-07133FF1CD86}"/>
+          </ac:spMkLst>
+        </pc:spChg>
+        <pc:spChg chg="del">
+          <ac:chgData name="Fatima Pillosu" userId="a6295d4dc9e22643" providerId="LiveId" clId="{87453732-75AC-4426-B5D3-B7C69C2D4F54}" dt="2026-01-23T00:19:57.956" v="1179" actId="21"/>
+          <ac:spMkLst>
+            <pc:docMk/>
+            <pc:sldMk cId="1573992039" sldId="256"/>
+            <ac:spMk id="138" creationId="{E3F5F678-30B9-E5A6-EDA8-349820A25D9E}"/>
           </ac:spMkLst>
         </pc:spChg>
         <pc:spChg chg="add mod">
@@ -775,16 +1055,24 @@
             <ac:spMk id="145" creationId="{88FD4609-03C7-48B1-EA84-375FFFEDBE06}"/>
           </ac:spMkLst>
         </pc:spChg>
-        <pc:spChg chg="add mod">
-          <ac:chgData name="Fatima Pillosu" userId="a6295d4dc9e22643" providerId="LiveId" clId="{87453732-75AC-4426-B5D3-B7C69C2D4F54}" dt="2026-01-22T23:34:37.804" v="1174" actId="1035"/>
+        <pc:spChg chg="del">
+          <ac:chgData name="Fatima Pillosu" userId="a6295d4dc9e22643" providerId="LiveId" clId="{87453732-75AC-4426-B5D3-B7C69C2D4F54}" dt="2026-01-23T00:19:57.956" v="1179" actId="21"/>
+          <ac:spMkLst>
+            <pc:docMk/>
+            <pc:sldMk cId="1573992039" sldId="256"/>
+            <ac:spMk id="146" creationId="{4C39D33D-2B26-F2D6-F8F4-09E6518093E9}"/>
+          </ac:spMkLst>
+        </pc:spChg>
+        <pc:spChg chg="add del mod">
+          <ac:chgData name="Fatima Pillosu" userId="a6295d4dc9e22643" providerId="LiveId" clId="{87453732-75AC-4426-B5D3-B7C69C2D4F54}" dt="2026-01-23T00:19:57.956" v="1179" actId="21"/>
           <ac:spMkLst>
             <pc:docMk/>
             <pc:sldMk cId="1573992039" sldId="256"/>
             <ac:spMk id="147" creationId="{D4A499F2-3420-098E-60B9-2B0BAC6336D7}"/>
           </ac:spMkLst>
         </pc:spChg>
-        <pc:spChg chg="mod">
-          <ac:chgData name="Fatima Pillosu" userId="a6295d4dc9e22643" providerId="LiveId" clId="{87453732-75AC-4426-B5D3-B7C69C2D4F54}" dt="2026-01-22T23:34:37.804" v="1174" actId="1035"/>
+        <pc:spChg chg="del mod">
+          <ac:chgData name="Fatima Pillosu" userId="a6295d4dc9e22643" providerId="LiveId" clId="{87453732-75AC-4426-B5D3-B7C69C2D4F54}" dt="2026-01-23T00:19:57.956" v="1179" actId="21"/>
           <ac:spMkLst>
             <pc:docMk/>
             <pc:sldMk cId="1573992039" sldId="256"/>
@@ -815,8 +1103,8 @@
             <ac:spMk id="154" creationId="{7160EB10-8701-2F92-B2E3-BD9975B33EAB}"/>
           </ac:spMkLst>
         </pc:spChg>
-        <pc:spChg chg="add mod">
-          <ac:chgData name="Fatima Pillosu" userId="a6295d4dc9e22643" providerId="LiveId" clId="{87453732-75AC-4426-B5D3-B7C69C2D4F54}" dt="2026-01-22T23:34:37.804" v="1174" actId="1035"/>
+        <pc:spChg chg="add del mod">
+          <ac:chgData name="Fatima Pillosu" userId="a6295d4dc9e22643" providerId="LiveId" clId="{87453732-75AC-4426-B5D3-B7C69C2D4F54}" dt="2026-01-23T00:19:57.956" v="1179" actId="21"/>
           <ac:spMkLst>
             <pc:docMk/>
             <pc:sldMk cId="1573992039" sldId="256"/>
@@ -839,12 +1127,68 @@
             <ac:spMk id="159" creationId="{5E7D516C-6098-CA78-A68A-A60E91A03B8B}"/>
           </ac:spMkLst>
         </pc:spChg>
-        <pc:spChg chg="add mod">
-          <ac:chgData name="Fatima Pillosu" userId="a6295d4dc9e22643" providerId="LiveId" clId="{87453732-75AC-4426-B5D3-B7C69C2D4F54}" dt="2026-01-22T23:34:23.477" v="1170"/>
+        <pc:spChg chg="del">
+          <ac:chgData name="Fatima Pillosu" userId="a6295d4dc9e22643" providerId="LiveId" clId="{87453732-75AC-4426-B5D3-B7C69C2D4F54}" dt="2026-01-23T00:19:57.956" v="1179" actId="21"/>
+          <ac:spMkLst>
+            <pc:docMk/>
+            <pc:sldMk cId="1573992039" sldId="256"/>
+            <ac:spMk id="161" creationId="{19C06D92-10F2-6629-738B-329DDCC22607}"/>
+          </ac:spMkLst>
+        </pc:spChg>
+        <pc:spChg chg="add del mod">
+          <ac:chgData name="Fatima Pillosu" userId="a6295d4dc9e22643" providerId="LiveId" clId="{87453732-75AC-4426-B5D3-B7C69C2D4F54}" dt="2026-01-23T00:19:57.956" v="1179" actId="21"/>
           <ac:spMkLst>
             <pc:docMk/>
             <pc:sldMk cId="1573992039" sldId="256"/>
             <ac:spMk id="163" creationId="{748BB081-753E-2804-7F05-2F111730D61F}"/>
+          </ac:spMkLst>
+        </pc:spChg>
+        <pc:spChg chg="add mod">
+          <ac:chgData name="Fatima Pillosu" userId="a6295d4dc9e22643" providerId="LiveId" clId="{87453732-75AC-4426-B5D3-B7C69C2D4F54}" dt="2026-01-23T00:38:00.791" v="1786" actId="1035"/>
+          <ac:spMkLst>
+            <pc:docMk/>
+            <pc:sldMk cId="1573992039" sldId="256"/>
+            <ac:spMk id="170" creationId="{B9DACAD8-B9E0-E96C-4ACB-CB40C5842B50}"/>
+          </ac:spMkLst>
+        </pc:spChg>
+        <pc:spChg chg="add mod">
+          <ac:chgData name="Fatima Pillosu" userId="a6295d4dc9e22643" providerId="LiveId" clId="{87453732-75AC-4426-B5D3-B7C69C2D4F54}" dt="2026-01-23T00:38:00.791" v="1786" actId="1035"/>
+          <ac:spMkLst>
+            <pc:docMk/>
+            <pc:sldMk cId="1573992039" sldId="256"/>
+            <ac:spMk id="172" creationId="{7F9A54EC-7677-98F3-A2A9-8D12ECCFFC18}"/>
+          </ac:spMkLst>
+        </pc:spChg>
+        <pc:spChg chg="add mod">
+          <ac:chgData name="Fatima Pillosu" userId="a6295d4dc9e22643" providerId="LiveId" clId="{87453732-75AC-4426-B5D3-B7C69C2D4F54}" dt="2026-01-23T00:38:00.791" v="1786" actId="1035"/>
+          <ac:spMkLst>
+            <pc:docMk/>
+            <pc:sldMk cId="1573992039" sldId="256"/>
+            <ac:spMk id="173" creationId="{69264F16-B69D-6B4B-97B4-69D4F6D781F7}"/>
+          </ac:spMkLst>
+        </pc:spChg>
+        <pc:spChg chg="mod">
+          <ac:chgData name="Fatima Pillosu" userId="a6295d4dc9e22643" providerId="LiveId" clId="{87453732-75AC-4426-B5D3-B7C69C2D4F54}" dt="2026-01-23T00:38:00.791" v="1786" actId="1035"/>
+          <ac:spMkLst>
+            <pc:docMk/>
+            <pc:sldMk cId="1573992039" sldId="256"/>
+            <ac:spMk id="174" creationId="{7B459E9B-BC54-D128-00BB-242594E7828F}"/>
+          </ac:spMkLst>
+        </pc:spChg>
+        <pc:spChg chg="mod">
+          <ac:chgData name="Fatima Pillosu" userId="a6295d4dc9e22643" providerId="LiveId" clId="{87453732-75AC-4426-B5D3-B7C69C2D4F54}" dt="2026-01-23T00:38:00.791" v="1786" actId="1035"/>
+          <ac:spMkLst>
+            <pc:docMk/>
+            <pc:sldMk cId="1573992039" sldId="256"/>
+            <ac:spMk id="177" creationId="{1398DA6C-3D5E-DD45-9EEB-E8E386580228}"/>
+          </ac:spMkLst>
+        </pc:spChg>
+        <pc:spChg chg="mod">
+          <ac:chgData name="Fatima Pillosu" userId="a6295d4dc9e22643" providerId="LiveId" clId="{87453732-75AC-4426-B5D3-B7C69C2D4F54}" dt="2026-01-23T00:38:00.791" v="1786" actId="1035"/>
+          <ac:spMkLst>
+            <pc:docMk/>
+            <pc:sldMk cId="1573992039" sldId="256"/>
+            <ac:spMk id="178" creationId="{8E734807-A9EC-31E5-F187-A3C719CDF111}"/>
           </ac:spMkLst>
         </pc:spChg>
         <pc:grpChg chg="del mod">
@@ -895,6 +1239,78 @@
             <ac:grpSpMk id="87" creationId="{CACA255C-6D4D-4370-696B-5DEA6A8AC9A4}"/>
           </ac:grpSpMkLst>
         </pc:grpChg>
+        <pc:picChg chg="del">
+          <ac:chgData name="Fatima Pillosu" userId="a6295d4dc9e22643" providerId="LiveId" clId="{87453732-75AC-4426-B5D3-B7C69C2D4F54}" dt="2026-01-23T00:29:08.133" v="1270" actId="478"/>
+          <ac:picMkLst>
+            <pc:docMk/>
+            <pc:sldMk cId="1573992039" sldId="256"/>
+            <ac:picMk id="31" creationId="{B4B20B6B-3DAA-796C-8EA6-D7D94A189AD2}"/>
+          </ac:picMkLst>
+        </pc:picChg>
+        <pc:picChg chg="add del mod">
+          <ac:chgData name="Fatima Pillosu" userId="a6295d4dc9e22643" providerId="LiveId" clId="{87453732-75AC-4426-B5D3-B7C69C2D4F54}" dt="2026-01-23T00:27:49.707" v="1259" actId="478"/>
+          <ac:picMkLst>
+            <pc:docMk/>
+            <pc:sldMk cId="1573992039" sldId="256"/>
+            <ac:picMk id="55" creationId="{DDD1B0BC-C353-C1B1-877E-EA8749306290}"/>
+          </ac:picMkLst>
+        </pc:picChg>
+        <pc:picChg chg="add mod modCrop">
+          <ac:chgData name="Fatima Pillosu" userId="a6295d4dc9e22643" providerId="LiveId" clId="{87453732-75AC-4426-B5D3-B7C69C2D4F54}" dt="2026-01-23T00:36:18.900" v="1661" actId="12789"/>
+          <ac:picMkLst>
+            <pc:docMk/>
+            <pc:sldMk cId="1573992039" sldId="256"/>
+            <ac:picMk id="57" creationId="{499574A5-DBB1-A835-3099-B6F210FD833C}"/>
+          </ac:picMkLst>
+        </pc:picChg>
+        <pc:picChg chg="add mod ord">
+          <ac:chgData name="Fatima Pillosu" userId="a6295d4dc9e22643" providerId="LiveId" clId="{87453732-75AC-4426-B5D3-B7C69C2D4F54}" dt="2026-01-23T00:29:05.491" v="1269" actId="167"/>
+          <ac:picMkLst>
+            <pc:docMk/>
+            <pc:sldMk cId="1573992039" sldId="256"/>
+            <ac:picMk id="58" creationId="{F45F7555-78D7-C8CF-FA3E-833AF9A9DC4F}"/>
+          </ac:picMkLst>
+        </pc:picChg>
+        <pc:picChg chg="add mod modCrop">
+          <ac:chgData name="Fatima Pillosu" userId="a6295d4dc9e22643" providerId="LiveId" clId="{87453732-75AC-4426-B5D3-B7C69C2D4F54}" dt="2026-01-23T00:36:18.900" v="1661" actId="12789"/>
+          <ac:picMkLst>
+            <pc:docMk/>
+            <pc:sldMk cId="1573992039" sldId="256"/>
+            <ac:picMk id="63" creationId="{33171DA4-F999-1BCA-6CDC-E62EB7A0D3A4}"/>
+          </ac:picMkLst>
+        </pc:picChg>
+        <pc:picChg chg="add mod modCrop">
+          <ac:chgData name="Fatima Pillosu" userId="a6295d4dc9e22643" providerId="LiveId" clId="{87453732-75AC-4426-B5D3-B7C69C2D4F54}" dt="2026-01-23T00:36:18.900" v="1661" actId="12789"/>
+          <ac:picMkLst>
+            <pc:docMk/>
+            <pc:sldMk cId="1573992039" sldId="256"/>
+            <ac:picMk id="64" creationId="{631A71EA-6234-2CC1-4520-6B28E47168AD}"/>
+          </ac:picMkLst>
+        </pc:picChg>
+        <pc:picChg chg="mod">
+          <ac:chgData name="Fatima Pillosu" userId="a6295d4dc9e22643" providerId="LiveId" clId="{87453732-75AC-4426-B5D3-B7C69C2D4F54}" dt="2026-01-23T00:38:00.791" v="1786" actId="1035"/>
+          <ac:picMkLst>
+            <pc:docMk/>
+            <pc:sldMk cId="1573992039" sldId="256"/>
+            <ac:picMk id="171" creationId="{499574A5-DBB1-A835-3099-B6F210FD833C}"/>
+          </ac:picMkLst>
+        </pc:picChg>
+        <pc:picChg chg="mod">
+          <ac:chgData name="Fatima Pillosu" userId="a6295d4dc9e22643" providerId="LiveId" clId="{87453732-75AC-4426-B5D3-B7C69C2D4F54}" dt="2026-01-23T00:38:00.791" v="1786" actId="1035"/>
+          <ac:picMkLst>
+            <pc:docMk/>
+            <pc:sldMk cId="1573992039" sldId="256"/>
+            <ac:picMk id="175" creationId="{33171DA4-F999-1BCA-6CDC-E62EB7A0D3A4}"/>
+          </ac:picMkLst>
+        </pc:picChg>
+        <pc:picChg chg="mod">
+          <ac:chgData name="Fatima Pillosu" userId="a6295d4dc9e22643" providerId="LiveId" clId="{87453732-75AC-4426-B5D3-B7C69C2D4F54}" dt="2026-01-23T00:38:00.791" v="1786" actId="1035"/>
+          <ac:picMkLst>
+            <pc:docMk/>
+            <pc:sldMk cId="1573992039" sldId="256"/>
+            <ac:picMk id="176" creationId="{631A71EA-6234-2CC1-4520-6B28E47168AD}"/>
+          </ac:picMkLst>
+        </pc:picChg>
         <pc:cxnChg chg="del">
           <ac:chgData name="Fatima Pillosu" userId="a6295d4dc9e22643" providerId="LiveId" clId="{87453732-75AC-4426-B5D3-B7C69C2D4F54}" dt="2026-01-22T22:57:57.325" v="214" actId="21"/>
           <ac:cxnSpMkLst>
@@ -978,15 +1394,15 @@
         </p:nvSpPr>
         <p:spPr>
           <a:xfrm>
-            <a:off x="719931" y="412312"/>
-            <a:ext cx="4319588" cy="877112"/>
+            <a:off x="431959" y="724600"/>
+            <a:ext cx="4895533" cy="1541439"/>
           </a:xfrm>
         </p:spPr>
         <p:txBody>
           <a:bodyPr anchor="b"/>
           <a:lstStyle>
             <a:lvl1pPr algn="ctr">
-              <a:defRPr sz="2204"/>
+              <a:defRPr sz="3779"/>
             </a:lvl1pPr>
           </a:lstStyle>
           <a:p>
@@ -1010,8 +1426,8 @@
         </p:nvSpPr>
         <p:spPr>
           <a:xfrm>
-            <a:off x="719931" y="1323249"/>
-            <a:ext cx="4319588" cy="608263"/>
+            <a:off x="719931" y="2325483"/>
+            <a:ext cx="4319588" cy="1068963"/>
           </a:xfrm>
         </p:spPr>
         <p:txBody>
@@ -1019,39 +1435,39 @@
           <a:lstStyle>
             <a:lvl1pPr marL="0" indent="0" algn="ctr">
               <a:buNone/>
-              <a:defRPr sz="882"/>
+              <a:defRPr sz="1512"/>
             </a:lvl1pPr>
-            <a:lvl2pPr marL="167975" indent="0" algn="ctr">
+            <a:lvl2pPr marL="287990" indent="0" algn="ctr">
               <a:buNone/>
-              <a:defRPr sz="735"/>
+              <a:defRPr sz="1260"/>
             </a:lvl2pPr>
-            <a:lvl3pPr marL="335951" indent="0" algn="ctr">
+            <a:lvl3pPr marL="575981" indent="0" algn="ctr">
               <a:buNone/>
-              <a:defRPr sz="661"/>
+              <a:defRPr sz="1134"/>
             </a:lvl3pPr>
-            <a:lvl4pPr marL="503926" indent="0" algn="ctr">
+            <a:lvl4pPr marL="863971" indent="0" algn="ctr">
               <a:buNone/>
-              <a:defRPr sz="588"/>
+              <a:defRPr sz="1008"/>
             </a:lvl4pPr>
-            <a:lvl5pPr marL="671901" indent="0" algn="ctr">
+            <a:lvl5pPr marL="1151961" indent="0" algn="ctr">
               <a:buNone/>
-              <a:defRPr sz="588"/>
+              <a:defRPr sz="1008"/>
             </a:lvl5pPr>
-            <a:lvl6pPr marL="839876" indent="0" algn="ctr">
+            <a:lvl6pPr marL="1439951" indent="0" algn="ctr">
               <a:buNone/>
-              <a:defRPr sz="588"/>
+              <a:defRPr sz="1008"/>
             </a:lvl6pPr>
-            <a:lvl7pPr marL="1007852" indent="0" algn="ctr">
+            <a:lvl7pPr marL="1727942" indent="0" algn="ctr">
               <a:buNone/>
-              <a:defRPr sz="588"/>
+              <a:defRPr sz="1008"/>
             </a:lvl7pPr>
-            <a:lvl8pPr marL="1175827" indent="0" algn="ctr">
+            <a:lvl8pPr marL="2015932" indent="0" algn="ctr">
               <a:buNone/>
-              <a:defRPr sz="588"/>
+              <a:defRPr sz="1008"/>
             </a:lvl8pPr>
-            <a:lvl9pPr marL="1343802" indent="0" algn="ctr">
+            <a:lvl9pPr marL="2303922" indent="0" algn="ctr">
               <a:buNone/>
-              <a:defRPr sz="588"/>
+              <a:defRPr sz="1008"/>
             </a:lvl9pPr>
           </a:lstStyle>
           <a:p>
@@ -1080,7 +1496,7 @@
           <a:p>
             <a:fld id="{1B0A7230-9229-4B4E-8CC9-329D15B7627B}" type="datetimeFigureOut">
               <a:rPr lang="en-GB" smtClean="0"/>
-              <a:t>22/01/2026</a:t>
+              <a:t>23/01/2026</a:t>
             </a:fld>
             <a:endParaRPr lang="en-GB"/>
           </a:p>
@@ -1131,7 +1547,7 @@
     </p:spTree>
     <p:extLst>
       <p:ext uri="{BB962C8B-B14F-4D97-AF65-F5344CB8AC3E}">
-        <p14:creationId xmlns:p14="http://schemas.microsoft.com/office/powerpoint/2010/main" val="966708158"/>
+        <p14:creationId xmlns:p14="http://schemas.microsoft.com/office/powerpoint/2010/main" val="2043131675"/>
       </p:ext>
     </p:extLst>
   </p:cSld>
@@ -1250,7 +1666,7 @@
           <a:p>
             <a:fld id="{1B0A7230-9229-4B4E-8CC9-329D15B7627B}" type="datetimeFigureOut">
               <a:rPr lang="en-GB" smtClean="0"/>
-              <a:t>22/01/2026</a:t>
+              <a:t>23/01/2026</a:t>
             </a:fld>
             <a:endParaRPr lang="en-GB"/>
           </a:p>
@@ -1301,7 +1717,7 @@
     </p:spTree>
     <p:extLst>
       <p:ext uri="{BB962C8B-B14F-4D97-AF65-F5344CB8AC3E}">
-        <p14:creationId xmlns:p14="http://schemas.microsoft.com/office/powerpoint/2010/main" val="1015252624"/>
+        <p14:creationId xmlns:p14="http://schemas.microsoft.com/office/powerpoint/2010/main" val="2089826117"/>
       </p:ext>
     </p:extLst>
   </p:cSld>
@@ -1340,8 +1756,8 @@
         </p:nvSpPr>
         <p:spPr>
           <a:xfrm>
-            <a:off x="4121607" y="134133"/>
-            <a:ext cx="1241881" cy="2135044"/>
+            <a:off x="4121607" y="235725"/>
+            <a:ext cx="1241881" cy="3752134"/>
           </a:xfrm>
         </p:spPr>
         <p:txBody>
@@ -1368,8 +1784,8 @@
         </p:nvSpPr>
         <p:spPr>
           <a:xfrm>
-            <a:off x="395962" y="134133"/>
-            <a:ext cx="3653651" cy="2135044"/>
+            <a:off x="395963" y="235725"/>
+            <a:ext cx="3653651" cy="3752134"/>
           </a:xfrm>
         </p:spPr>
         <p:txBody>
@@ -1430,7 +1846,7 @@
           <a:p>
             <a:fld id="{1B0A7230-9229-4B4E-8CC9-329D15B7627B}" type="datetimeFigureOut">
               <a:rPr lang="en-GB" smtClean="0"/>
-              <a:t>22/01/2026</a:t>
+              <a:t>23/01/2026</a:t>
             </a:fld>
             <a:endParaRPr lang="en-GB"/>
           </a:p>
@@ -1481,7 +1897,7 @@
     </p:spTree>
     <p:extLst>
       <p:ext uri="{BB962C8B-B14F-4D97-AF65-F5344CB8AC3E}">
-        <p14:creationId xmlns:p14="http://schemas.microsoft.com/office/powerpoint/2010/main" val="2190298995"/>
+        <p14:creationId xmlns:p14="http://schemas.microsoft.com/office/powerpoint/2010/main" val="2129849350"/>
       </p:ext>
     </p:extLst>
   </p:cSld>
@@ -1600,7 +2016,7 @@
           <a:p>
             <a:fld id="{1B0A7230-9229-4B4E-8CC9-329D15B7627B}" type="datetimeFigureOut">
               <a:rPr lang="en-GB" smtClean="0"/>
-              <a:t>22/01/2026</a:t>
+              <a:t>23/01/2026</a:t>
             </a:fld>
             <a:endParaRPr lang="en-GB"/>
           </a:p>
@@ -1651,7 +2067,7 @@
     </p:spTree>
     <p:extLst>
       <p:ext uri="{BB962C8B-B14F-4D97-AF65-F5344CB8AC3E}">
-        <p14:creationId xmlns:p14="http://schemas.microsoft.com/office/powerpoint/2010/main" val="1379433252"/>
+        <p14:creationId xmlns:p14="http://schemas.microsoft.com/office/powerpoint/2010/main" val="4029098185"/>
       </p:ext>
     </p:extLst>
   </p:cSld>
@@ -1690,15 +2106,15 @@
         </p:nvSpPr>
         <p:spPr>
           <a:xfrm>
-            <a:off x="392962" y="628091"/>
-            <a:ext cx="4967526" cy="1047985"/>
+            <a:off x="392963" y="1103811"/>
+            <a:ext cx="4967526" cy="1841732"/>
           </a:xfrm>
         </p:spPr>
         <p:txBody>
           <a:bodyPr anchor="b"/>
           <a:lstStyle>
             <a:lvl1pPr>
-              <a:defRPr sz="2204"/>
+              <a:defRPr sz="3779"/>
             </a:lvl1pPr>
           </a:lstStyle>
           <a:p>
@@ -1722,8 +2138,8 @@
         </p:nvSpPr>
         <p:spPr>
           <a:xfrm>
-            <a:off x="392962" y="1685991"/>
-            <a:ext cx="4967526" cy="551110"/>
+            <a:off x="392963" y="2962967"/>
+            <a:ext cx="4967526" cy="968524"/>
           </a:xfrm>
         </p:spPr>
         <p:txBody>
@@ -1731,7 +2147,7 @@
           <a:lstStyle>
             <a:lvl1pPr marL="0" indent="0">
               <a:buNone/>
-              <a:defRPr sz="882">
+              <a:defRPr sz="1512">
                 <a:solidFill>
                   <a:schemeClr val="tx1">
                     <a:tint val="82000"/>
@@ -1739,9 +2155,9 @@
                 </a:solidFill>
               </a:defRPr>
             </a:lvl1pPr>
-            <a:lvl2pPr marL="167975" indent="0">
+            <a:lvl2pPr marL="287990" indent="0">
               <a:buNone/>
-              <a:defRPr sz="735">
+              <a:defRPr sz="1260">
                 <a:solidFill>
                   <a:schemeClr val="tx1">
                     <a:tint val="82000"/>
@@ -1749,9 +2165,9 @@
                 </a:solidFill>
               </a:defRPr>
             </a:lvl2pPr>
-            <a:lvl3pPr marL="335951" indent="0">
+            <a:lvl3pPr marL="575981" indent="0">
               <a:buNone/>
-              <a:defRPr sz="661">
+              <a:defRPr sz="1134">
                 <a:solidFill>
                   <a:schemeClr val="tx1">
                     <a:tint val="82000"/>
@@ -1759,9 +2175,9 @@
                 </a:solidFill>
               </a:defRPr>
             </a:lvl3pPr>
-            <a:lvl4pPr marL="503926" indent="0">
+            <a:lvl4pPr marL="863971" indent="0">
               <a:buNone/>
-              <a:defRPr sz="588">
+              <a:defRPr sz="1008">
                 <a:solidFill>
                   <a:schemeClr val="tx1">
                     <a:tint val="82000"/>
@@ -1769,9 +2185,9 @@
                 </a:solidFill>
               </a:defRPr>
             </a:lvl4pPr>
-            <a:lvl5pPr marL="671901" indent="0">
+            <a:lvl5pPr marL="1151961" indent="0">
               <a:buNone/>
-              <a:defRPr sz="588">
+              <a:defRPr sz="1008">
                 <a:solidFill>
                   <a:schemeClr val="tx1">
                     <a:tint val="82000"/>
@@ -1779,9 +2195,9 @@
                 </a:solidFill>
               </a:defRPr>
             </a:lvl5pPr>
-            <a:lvl6pPr marL="839876" indent="0">
+            <a:lvl6pPr marL="1439951" indent="0">
               <a:buNone/>
-              <a:defRPr sz="588">
+              <a:defRPr sz="1008">
                 <a:solidFill>
                   <a:schemeClr val="tx1">
                     <a:tint val="82000"/>
@@ -1789,9 +2205,9 @@
                 </a:solidFill>
               </a:defRPr>
             </a:lvl6pPr>
-            <a:lvl7pPr marL="1007852" indent="0">
+            <a:lvl7pPr marL="1727942" indent="0">
               <a:buNone/>
-              <a:defRPr sz="588">
+              <a:defRPr sz="1008">
                 <a:solidFill>
                   <a:schemeClr val="tx1">
                     <a:tint val="82000"/>
@@ -1799,9 +2215,9 @@
                 </a:solidFill>
               </a:defRPr>
             </a:lvl7pPr>
-            <a:lvl8pPr marL="1175827" indent="0">
+            <a:lvl8pPr marL="2015932" indent="0">
               <a:buNone/>
-              <a:defRPr sz="588">
+              <a:defRPr sz="1008">
                 <a:solidFill>
                   <a:schemeClr val="tx1">
                     <a:tint val="82000"/>
@@ -1809,9 +2225,9 @@
                 </a:solidFill>
               </a:defRPr>
             </a:lvl8pPr>
-            <a:lvl9pPr marL="1343802" indent="0">
+            <a:lvl9pPr marL="2303922" indent="0">
               <a:buNone/>
-              <a:defRPr sz="588">
+              <a:defRPr sz="1008">
                 <a:solidFill>
                   <a:schemeClr val="tx1">
                     <a:tint val="82000"/>
@@ -1846,7 +2262,7 @@
           <a:p>
             <a:fld id="{1B0A7230-9229-4B4E-8CC9-329D15B7627B}" type="datetimeFigureOut">
               <a:rPr lang="en-GB" smtClean="0"/>
-              <a:t>22/01/2026</a:t>
+              <a:t>23/01/2026</a:t>
             </a:fld>
             <a:endParaRPr lang="en-GB"/>
           </a:p>
@@ -1897,7 +2313,7 @@
     </p:spTree>
     <p:extLst>
       <p:ext uri="{BB962C8B-B14F-4D97-AF65-F5344CB8AC3E}">
-        <p14:creationId xmlns:p14="http://schemas.microsoft.com/office/powerpoint/2010/main" val="4022177778"/>
+        <p14:creationId xmlns:p14="http://schemas.microsoft.com/office/powerpoint/2010/main" val="3905935856"/>
       </p:ext>
     </p:extLst>
   </p:cSld>
@@ -1959,8 +2375,8 @@
         </p:nvSpPr>
         <p:spPr>
           <a:xfrm>
-            <a:off x="395962" y="670664"/>
-            <a:ext cx="2447766" cy="1598513"/>
+            <a:off x="395962" y="1178627"/>
+            <a:ext cx="2447766" cy="2809232"/>
           </a:xfrm>
         </p:spPr>
         <p:txBody>
@@ -2016,8 +2432,8 @@
         </p:nvSpPr>
         <p:spPr>
           <a:xfrm>
-            <a:off x="2915722" y="670664"/>
-            <a:ext cx="2447766" cy="1598513"/>
+            <a:off x="2915722" y="1178627"/>
+            <a:ext cx="2447766" cy="2809232"/>
           </a:xfrm>
         </p:spPr>
         <p:txBody>
@@ -2078,7 +2494,7 @@
           <a:p>
             <a:fld id="{1B0A7230-9229-4B4E-8CC9-329D15B7627B}" type="datetimeFigureOut">
               <a:rPr lang="en-GB" smtClean="0"/>
-              <a:t>22/01/2026</a:t>
+              <a:t>23/01/2026</a:t>
             </a:fld>
             <a:endParaRPr lang="en-GB"/>
           </a:p>
@@ -2129,7 +2545,7 @@
     </p:spTree>
     <p:extLst>
       <p:ext uri="{BB962C8B-B14F-4D97-AF65-F5344CB8AC3E}">
-        <p14:creationId xmlns:p14="http://schemas.microsoft.com/office/powerpoint/2010/main" val="3030428987"/>
+        <p14:creationId xmlns:p14="http://schemas.microsoft.com/office/powerpoint/2010/main" val="52126247"/>
       </p:ext>
     </p:extLst>
   </p:cSld>
@@ -2168,8 +2584,8 @@
         </p:nvSpPr>
         <p:spPr>
           <a:xfrm>
-            <a:off x="396712" y="134133"/>
-            <a:ext cx="4967526" cy="486960"/>
+            <a:off x="396712" y="235726"/>
+            <a:ext cx="4967526" cy="855786"/>
           </a:xfrm>
         </p:spPr>
         <p:txBody>
@@ -2196,8 +2612,8 @@
         </p:nvSpPr>
         <p:spPr>
           <a:xfrm>
-            <a:off x="396713" y="617594"/>
-            <a:ext cx="2436517" cy="302673"/>
+            <a:off x="396713" y="1085362"/>
+            <a:ext cx="2436517" cy="531919"/>
           </a:xfrm>
         </p:spPr>
         <p:txBody>
@@ -2205,39 +2621,39 @@
           <a:lstStyle>
             <a:lvl1pPr marL="0" indent="0">
               <a:buNone/>
-              <a:defRPr sz="882" b="1"/>
+              <a:defRPr sz="1512" b="1"/>
             </a:lvl1pPr>
-            <a:lvl2pPr marL="167975" indent="0">
+            <a:lvl2pPr marL="287990" indent="0">
               <a:buNone/>
-              <a:defRPr sz="735" b="1"/>
+              <a:defRPr sz="1260" b="1"/>
             </a:lvl2pPr>
-            <a:lvl3pPr marL="335951" indent="0">
+            <a:lvl3pPr marL="575981" indent="0">
               <a:buNone/>
-              <a:defRPr sz="661" b="1"/>
+              <a:defRPr sz="1134" b="1"/>
             </a:lvl3pPr>
-            <a:lvl4pPr marL="503926" indent="0">
+            <a:lvl4pPr marL="863971" indent="0">
               <a:buNone/>
-              <a:defRPr sz="588" b="1"/>
+              <a:defRPr sz="1008" b="1"/>
             </a:lvl4pPr>
-            <a:lvl5pPr marL="671901" indent="0">
+            <a:lvl5pPr marL="1151961" indent="0">
               <a:buNone/>
-              <a:defRPr sz="588" b="1"/>
+              <a:defRPr sz="1008" b="1"/>
             </a:lvl5pPr>
-            <a:lvl6pPr marL="839876" indent="0">
+            <a:lvl6pPr marL="1439951" indent="0">
               <a:buNone/>
-              <a:defRPr sz="588" b="1"/>
+              <a:defRPr sz="1008" b="1"/>
             </a:lvl6pPr>
-            <a:lvl7pPr marL="1007852" indent="0">
+            <a:lvl7pPr marL="1727942" indent="0">
               <a:buNone/>
-              <a:defRPr sz="588" b="1"/>
+              <a:defRPr sz="1008" b="1"/>
             </a:lvl7pPr>
-            <a:lvl8pPr marL="1175827" indent="0">
+            <a:lvl8pPr marL="2015932" indent="0">
               <a:buNone/>
-              <a:defRPr sz="588" b="1"/>
+              <a:defRPr sz="1008" b="1"/>
             </a:lvl8pPr>
-            <a:lvl9pPr marL="1343802" indent="0">
+            <a:lvl9pPr marL="2303922" indent="0">
               <a:buNone/>
-              <a:defRPr sz="588" b="1"/>
+              <a:defRPr sz="1008" b="1"/>
             </a:lvl9pPr>
           </a:lstStyle>
           <a:p>
@@ -2261,8 +2677,8 @@
         </p:nvSpPr>
         <p:spPr>
           <a:xfrm>
-            <a:off x="396713" y="920267"/>
-            <a:ext cx="2436517" cy="1353575"/>
+            <a:off x="396713" y="1617281"/>
+            <a:ext cx="2436517" cy="2378777"/>
           </a:xfrm>
         </p:spPr>
         <p:txBody>
@@ -2318,8 +2734,8 @@
         </p:nvSpPr>
         <p:spPr>
           <a:xfrm>
-            <a:off x="2915722" y="617594"/>
-            <a:ext cx="2448516" cy="302673"/>
+            <a:off x="2915722" y="1085362"/>
+            <a:ext cx="2448516" cy="531919"/>
           </a:xfrm>
         </p:spPr>
         <p:txBody>
@@ -2327,39 +2743,39 @@
           <a:lstStyle>
             <a:lvl1pPr marL="0" indent="0">
               <a:buNone/>
-              <a:defRPr sz="882" b="1"/>
+              <a:defRPr sz="1512" b="1"/>
             </a:lvl1pPr>
-            <a:lvl2pPr marL="167975" indent="0">
+            <a:lvl2pPr marL="287990" indent="0">
               <a:buNone/>
-              <a:defRPr sz="735" b="1"/>
+              <a:defRPr sz="1260" b="1"/>
             </a:lvl2pPr>
-            <a:lvl3pPr marL="335951" indent="0">
+            <a:lvl3pPr marL="575981" indent="0">
               <a:buNone/>
-              <a:defRPr sz="661" b="1"/>
+              <a:defRPr sz="1134" b="1"/>
             </a:lvl3pPr>
-            <a:lvl4pPr marL="503926" indent="0">
+            <a:lvl4pPr marL="863971" indent="0">
               <a:buNone/>
-              <a:defRPr sz="588" b="1"/>
+              <a:defRPr sz="1008" b="1"/>
             </a:lvl4pPr>
-            <a:lvl5pPr marL="671901" indent="0">
+            <a:lvl5pPr marL="1151961" indent="0">
               <a:buNone/>
-              <a:defRPr sz="588" b="1"/>
+              <a:defRPr sz="1008" b="1"/>
             </a:lvl5pPr>
-            <a:lvl6pPr marL="839876" indent="0">
+            <a:lvl6pPr marL="1439951" indent="0">
               <a:buNone/>
-              <a:defRPr sz="588" b="1"/>
+              <a:defRPr sz="1008" b="1"/>
             </a:lvl6pPr>
-            <a:lvl7pPr marL="1007852" indent="0">
+            <a:lvl7pPr marL="1727942" indent="0">
               <a:buNone/>
-              <a:defRPr sz="588" b="1"/>
+              <a:defRPr sz="1008" b="1"/>
             </a:lvl7pPr>
-            <a:lvl8pPr marL="1175827" indent="0">
+            <a:lvl8pPr marL="2015932" indent="0">
               <a:buNone/>
-              <a:defRPr sz="588" b="1"/>
+              <a:defRPr sz="1008" b="1"/>
             </a:lvl8pPr>
-            <a:lvl9pPr marL="1343802" indent="0">
+            <a:lvl9pPr marL="2303922" indent="0">
               <a:buNone/>
-              <a:defRPr sz="588" b="1"/>
+              <a:defRPr sz="1008" b="1"/>
             </a:lvl9pPr>
           </a:lstStyle>
           <a:p>
@@ -2383,8 +2799,8 @@
         </p:nvSpPr>
         <p:spPr>
           <a:xfrm>
-            <a:off x="2915722" y="920267"/>
-            <a:ext cx="2448516" cy="1353575"/>
+            <a:off x="2915722" y="1617281"/>
+            <a:ext cx="2448516" cy="2378777"/>
           </a:xfrm>
         </p:spPr>
         <p:txBody>
@@ -2445,7 +2861,7 @@
           <a:p>
             <a:fld id="{1B0A7230-9229-4B4E-8CC9-329D15B7627B}" type="datetimeFigureOut">
               <a:rPr lang="en-GB" smtClean="0"/>
-              <a:t>22/01/2026</a:t>
+              <a:t>23/01/2026</a:t>
             </a:fld>
             <a:endParaRPr lang="en-GB"/>
           </a:p>
@@ -2496,7 +2912,7 @@
     </p:spTree>
     <p:extLst>
       <p:ext uri="{BB962C8B-B14F-4D97-AF65-F5344CB8AC3E}">
-        <p14:creationId xmlns:p14="http://schemas.microsoft.com/office/powerpoint/2010/main" val="3726321075"/>
+        <p14:creationId xmlns:p14="http://schemas.microsoft.com/office/powerpoint/2010/main" val="2714661730"/>
       </p:ext>
     </p:extLst>
   </p:cSld>
@@ -2563,7 +2979,7 @@
           <a:p>
             <a:fld id="{1B0A7230-9229-4B4E-8CC9-329D15B7627B}" type="datetimeFigureOut">
               <a:rPr lang="en-GB" smtClean="0"/>
-              <a:t>22/01/2026</a:t>
+              <a:t>23/01/2026</a:t>
             </a:fld>
             <a:endParaRPr lang="en-GB"/>
           </a:p>
@@ -2614,7 +3030,7 @@
     </p:spTree>
     <p:extLst>
       <p:ext uri="{BB962C8B-B14F-4D97-AF65-F5344CB8AC3E}">
-        <p14:creationId xmlns:p14="http://schemas.microsoft.com/office/powerpoint/2010/main" val="1138051211"/>
+        <p14:creationId xmlns:p14="http://schemas.microsoft.com/office/powerpoint/2010/main" val="2753695947"/>
       </p:ext>
     </p:extLst>
   </p:cSld>
@@ -2658,7 +3074,7 @@
           <a:p>
             <a:fld id="{1B0A7230-9229-4B4E-8CC9-329D15B7627B}" type="datetimeFigureOut">
               <a:rPr lang="en-GB" smtClean="0"/>
-              <a:t>22/01/2026</a:t>
+              <a:t>23/01/2026</a:t>
             </a:fld>
             <a:endParaRPr lang="en-GB"/>
           </a:p>
@@ -2709,7 +3125,7 @@
     </p:spTree>
     <p:extLst>
       <p:ext uri="{BB962C8B-B14F-4D97-AF65-F5344CB8AC3E}">
-        <p14:creationId xmlns:p14="http://schemas.microsoft.com/office/powerpoint/2010/main" val="2601565038"/>
+        <p14:creationId xmlns:p14="http://schemas.microsoft.com/office/powerpoint/2010/main" val="2494000983"/>
       </p:ext>
     </p:extLst>
   </p:cSld>
@@ -2748,15 +3164,15 @@
         </p:nvSpPr>
         <p:spPr>
           <a:xfrm>
-            <a:off x="396713" y="167958"/>
-            <a:ext cx="1857572" cy="587851"/>
+            <a:off x="396712" y="295169"/>
+            <a:ext cx="1857573" cy="1033092"/>
           </a:xfrm>
         </p:spPr>
         <p:txBody>
           <a:bodyPr anchor="b"/>
           <a:lstStyle>
             <a:lvl1pPr>
-              <a:defRPr sz="1176"/>
+              <a:defRPr sz="2016"/>
             </a:lvl1pPr>
           </a:lstStyle>
           <a:p>
@@ -2780,39 +3196,39 @@
         </p:nvSpPr>
         <p:spPr>
           <a:xfrm>
-            <a:off x="2448516" y="362742"/>
-            <a:ext cx="2915722" cy="1790381"/>
+            <a:off x="2448516" y="637484"/>
+            <a:ext cx="2915722" cy="3146422"/>
           </a:xfrm>
         </p:spPr>
         <p:txBody>
           <a:bodyPr/>
           <a:lstStyle>
             <a:lvl1pPr>
-              <a:defRPr sz="1176"/>
+              <a:defRPr sz="2016"/>
             </a:lvl1pPr>
             <a:lvl2pPr>
-              <a:defRPr sz="1029"/>
+              <a:defRPr sz="1764"/>
             </a:lvl2pPr>
             <a:lvl3pPr>
-              <a:defRPr sz="882"/>
+              <a:defRPr sz="1512"/>
             </a:lvl3pPr>
             <a:lvl4pPr>
-              <a:defRPr sz="735"/>
+              <a:defRPr sz="1260"/>
             </a:lvl4pPr>
             <a:lvl5pPr>
-              <a:defRPr sz="735"/>
+              <a:defRPr sz="1260"/>
             </a:lvl5pPr>
             <a:lvl6pPr>
-              <a:defRPr sz="735"/>
+              <a:defRPr sz="1260"/>
             </a:lvl6pPr>
             <a:lvl7pPr>
-              <a:defRPr sz="735"/>
+              <a:defRPr sz="1260"/>
             </a:lvl7pPr>
             <a:lvl8pPr>
-              <a:defRPr sz="735"/>
+              <a:defRPr sz="1260"/>
             </a:lvl8pPr>
             <a:lvl9pPr>
-              <a:defRPr sz="735"/>
+              <a:defRPr sz="1260"/>
             </a:lvl9pPr>
           </a:lstStyle>
           <a:p>
@@ -2865,8 +3281,8 @@
         </p:nvSpPr>
         <p:spPr>
           <a:xfrm>
-            <a:off x="396713" y="755809"/>
-            <a:ext cx="1857572" cy="1400229"/>
+            <a:off x="396712" y="1328261"/>
+            <a:ext cx="1857573" cy="2460769"/>
           </a:xfrm>
         </p:spPr>
         <p:txBody>
@@ -2874,39 +3290,39 @@
           <a:lstStyle>
             <a:lvl1pPr marL="0" indent="0">
               <a:buNone/>
-              <a:defRPr sz="588"/>
+              <a:defRPr sz="1008"/>
             </a:lvl1pPr>
-            <a:lvl2pPr marL="167975" indent="0">
+            <a:lvl2pPr marL="287990" indent="0">
               <a:buNone/>
-              <a:defRPr sz="514"/>
+              <a:defRPr sz="882"/>
             </a:lvl2pPr>
-            <a:lvl3pPr marL="335951" indent="0">
+            <a:lvl3pPr marL="575981" indent="0">
               <a:buNone/>
-              <a:defRPr sz="441"/>
+              <a:defRPr sz="756"/>
             </a:lvl3pPr>
-            <a:lvl4pPr marL="503926" indent="0">
+            <a:lvl4pPr marL="863971" indent="0">
               <a:buNone/>
-              <a:defRPr sz="367"/>
+              <a:defRPr sz="630"/>
             </a:lvl4pPr>
-            <a:lvl5pPr marL="671901" indent="0">
+            <a:lvl5pPr marL="1151961" indent="0">
               <a:buNone/>
-              <a:defRPr sz="367"/>
+              <a:defRPr sz="630"/>
             </a:lvl5pPr>
-            <a:lvl6pPr marL="839876" indent="0">
+            <a:lvl6pPr marL="1439951" indent="0">
               <a:buNone/>
-              <a:defRPr sz="367"/>
+              <a:defRPr sz="630"/>
             </a:lvl6pPr>
-            <a:lvl7pPr marL="1007852" indent="0">
+            <a:lvl7pPr marL="1727942" indent="0">
               <a:buNone/>
-              <a:defRPr sz="367"/>
+              <a:defRPr sz="630"/>
             </a:lvl7pPr>
-            <a:lvl8pPr marL="1175827" indent="0">
+            <a:lvl8pPr marL="2015932" indent="0">
               <a:buNone/>
-              <a:defRPr sz="367"/>
+              <a:defRPr sz="630"/>
             </a:lvl8pPr>
-            <a:lvl9pPr marL="1343802" indent="0">
+            <a:lvl9pPr marL="2303922" indent="0">
               <a:buNone/>
-              <a:defRPr sz="367"/>
+              <a:defRPr sz="630"/>
             </a:lvl9pPr>
           </a:lstStyle>
           <a:p>
@@ -2935,7 +3351,7 @@
           <a:p>
             <a:fld id="{1B0A7230-9229-4B4E-8CC9-329D15B7627B}" type="datetimeFigureOut">
               <a:rPr lang="en-GB" smtClean="0"/>
-              <a:t>22/01/2026</a:t>
+              <a:t>23/01/2026</a:t>
             </a:fld>
             <a:endParaRPr lang="en-GB"/>
           </a:p>
@@ -2986,7 +3402,7 @@
     </p:spTree>
     <p:extLst>
       <p:ext uri="{BB962C8B-B14F-4D97-AF65-F5344CB8AC3E}">
-        <p14:creationId xmlns:p14="http://schemas.microsoft.com/office/powerpoint/2010/main" val="2030451596"/>
+        <p14:creationId xmlns:p14="http://schemas.microsoft.com/office/powerpoint/2010/main" val="1519721966"/>
       </p:ext>
     </p:extLst>
   </p:cSld>
@@ -3025,15 +3441,15 @@
         </p:nvSpPr>
         <p:spPr>
           <a:xfrm>
-            <a:off x="396713" y="167958"/>
-            <a:ext cx="1857572" cy="587851"/>
+            <a:off x="396712" y="295169"/>
+            <a:ext cx="1857573" cy="1033092"/>
           </a:xfrm>
         </p:spPr>
         <p:txBody>
           <a:bodyPr anchor="b"/>
           <a:lstStyle>
             <a:lvl1pPr>
-              <a:defRPr sz="1176"/>
+              <a:defRPr sz="2016"/>
             </a:lvl1pPr>
           </a:lstStyle>
           <a:p>
@@ -3057,8 +3473,8 @@
         </p:nvSpPr>
         <p:spPr>
           <a:xfrm>
-            <a:off x="2448516" y="362742"/>
-            <a:ext cx="2915722" cy="1790381"/>
+            <a:off x="2448516" y="637484"/>
+            <a:ext cx="2915722" cy="3146422"/>
           </a:xfrm>
         </p:spPr>
         <p:txBody>
@@ -3066,39 +3482,39 @@
           <a:lstStyle>
             <a:lvl1pPr marL="0" indent="0">
               <a:buNone/>
-              <a:defRPr sz="1176"/>
+              <a:defRPr sz="2016"/>
             </a:lvl1pPr>
-            <a:lvl2pPr marL="167975" indent="0">
+            <a:lvl2pPr marL="287990" indent="0">
               <a:buNone/>
-              <a:defRPr sz="1029"/>
+              <a:defRPr sz="1764"/>
             </a:lvl2pPr>
-            <a:lvl3pPr marL="335951" indent="0">
+            <a:lvl3pPr marL="575981" indent="0">
               <a:buNone/>
-              <a:defRPr sz="882"/>
+              <a:defRPr sz="1512"/>
             </a:lvl3pPr>
-            <a:lvl4pPr marL="503926" indent="0">
+            <a:lvl4pPr marL="863971" indent="0">
               <a:buNone/>
-              <a:defRPr sz="735"/>
+              <a:defRPr sz="1260"/>
             </a:lvl4pPr>
-            <a:lvl5pPr marL="671901" indent="0">
+            <a:lvl5pPr marL="1151961" indent="0">
               <a:buNone/>
-              <a:defRPr sz="735"/>
+              <a:defRPr sz="1260"/>
             </a:lvl5pPr>
-            <a:lvl6pPr marL="839876" indent="0">
+            <a:lvl6pPr marL="1439951" indent="0">
               <a:buNone/>
-              <a:defRPr sz="735"/>
+              <a:defRPr sz="1260"/>
             </a:lvl6pPr>
-            <a:lvl7pPr marL="1007852" indent="0">
+            <a:lvl7pPr marL="1727942" indent="0">
               <a:buNone/>
-              <a:defRPr sz="735"/>
+              <a:defRPr sz="1260"/>
             </a:lvl7pPr>
-            <a:lvl8pPr marL="1175827" indent="0">
+            <a:lvl8pPr marL="2015932" indent="0">
               <a:buNone/>
-              <a:defRPr sz="735"/>
+              <a:defRPr sz="1260"/>
             </a:lvl8pPr>
-            <a:lvl9pPr marL="1343802" indent="0">
+            <a:lvl9pPr marL="2303922" indent="0">
               <a:buNone/>
-              <a:defRPr sz="735"/>
+              <a:defRPr sz="1260"/>
             </a:lvl9pPr>
           </a:lstStyle>
           <a:p>
@@ -3122,8 +3538,8 @@
         </p:nvSpPr>
         <p:spPr>
           <a:xfrm>
-            <a:off x="396713" y="755809"/>
-            <a:ext cx="1857572" cy="1400229"/>
+            <a:off x="396712" y="1328261"/>
+            <a:ext cx="1857573" cy="2460769"/>
           </a:xfrm>
         </p:spPr>
         <p:txBody>
@@ -3131,39 +3547,39 @@
           <a:lstStyle>
             <a:lvl1pPr marL="0" indent="0">
               <a:buNone/>
-              <a:defRPr sz="588"/>
+              <a:defRPr sz="1008"/>
             </a:lvl1pPr>
-            <a:lvl2pPr marL="167975" indent="0">
+            <a:lvl2pPr marL="287990" indent="0">
               <a:buNone/>
-              <a:defRPr sz="514"/>
+              <a:defRPr sz="882"/>
             </a:lvl2pPr>
-            <a:lvl3pPr marL="335951" indent="0">
+            <a:lvl3pPr marL="575981" indent="0">
               <a:buNone/>
-              <a:defRPr sz="441"/>
+              <a:defRPr sz="756"/>
             </a:lvl3pPr>
-            <a:lvl4pPr marL="503926" indent="0">
+            <a:lvl4pPr marL="863971" indent="0">
               <a:buNone/>
-              <a:defRPr sz="367"/>
+              <a:defRPr sz="630"/>
             </a:lvl4pPr>
-            <a:lvl5pPr marL="671901" indent="0">
+            <a:lvl5pPr marL="1151961" indent="0">
               <a:buNone/>
-              <a:defRPr sz="367"/>
+              <a:defRPr sz="630"/>
             </a:lvl5pPr>
-            <a:lvl6pPr marL="839876" indent="0">
+            <a:lvl6pPr marL="1439951" indent="0">
               <a:buNone/>
-              <a:defRPr sz="367"/>
+              <a:defRPr sz="630"/>
             </a:lvl6pPr>
-            <a:lvl7pPr marL="1007852" indent="0">
+            <a:lvl7pPr marL="1727942" indent="0">
               <a:buNone/>
-              <a:defRPr sz="367"/>
+              <a:defRPr sz="630"/>
             </a:lvl7pPr>
-            <a:lvl8pPr marL="1175827" indent="0">
+            <a:lvl8pPr marL="2015932" indent="0">
               <a:buNone/>
-              <a:defRPr sz="367"/>
+              <a:defRPr sz="630"/>
             </a:lvl8pPr>
-            <a:lvl9pPr marL="1343802" indent="0">
+            <a:lvl9pPr marL="2303922" indent="0">
               <a:buNone/>
-              <a:defRPr sz="367"/>
+              <a:defRPr sz="630"/>
             </a:lvl9pPr>
           </a:lstStyle>
           <a:p>
@@ -3192,7 +3608,7 @@
           <a:p>
             <a:fld id="{1B0A7230-9229-4B4E-8CC9-329D15B7627B}" type="datetimeFigureOut">
               <a:rPr lang="en-GB" smtClean="0"/>
-              <a:t>22/01/2026</a:t>
+              <a:t>23/01/2026</a:t>
             </a:fld>
             <a:endParaRPr lang="en-GB"/>
           </a:p>
@@ -3243,7 +3659,7 @@
     </p:spTree>
     <p:extLst>
       <p:ext uri="{BB962C8B-B14F-4D97-AF65-F5344CB8AC3E}">
-        <p14:creationId xmlns:p14="http://schemas.microsoft.com/office/powerpoint/2010/main" val="281532981"/>
+        <p14:creationId xmlns:p14="http://schemas.microsoft.com/office/powerpoint/2010/main" val="225792783"/>
       </p:ext>
     </p:extLst>
   </p:cSld>
@@ -3287,8 +3703,8 @@
         </p:nvSpPr>
         <p:spPr>
           <a:xfrm>
-            <a:off x="395962" y="134133"/>
-            <a:ext cx="4967526" cy="486960"/>
+            <a:off x="395962" y="235726"/>
+            <a:ext cx="4967526" cy="855786"/>
           </a:xfrm>
           <a:prstGeom prst="rect">
             <a:avLst/>
@@ -3320,8 +3736,8 @@
         </p:nvSpPr>
         <p:spPr>
           <a:xfrm>
-            <a:off x="395962" y="670664"/>
-            <a:ext cx="4967526" cy="1598513"/>
+            <a:off x="395962" y="1178627"/>
+            <a:ext cx="4967526" cy="2809232"/>
           </a:xfrm>
           <a:prstGeom prst="rect">
             <a:avLst/>
@@ -3382,8 +3798,8 @@
         </p:nvSpPr>
         <p:spPr>
           <a:xfrm>
-            <a:off x="395962" y="2335076"/>
-            <a:ext cx="1295876" cy="134133"/>
+            <a:off x="395962" y="4103673"/>
+            <a:ext cx="1295876" cy="235725"/>
           </a:xfrm>
           <a:prstGeom prst="rect">
             <a:avLst/>
@@ -3393,7 +3809,7 @@
           <a:bodyPr vert="horz" lIns="91440" tIns="45720" rIns="91440" bIns="45720" rtlCol="0" anchor="ctr"/>
           <a:lstStyle>
             <a:lvl1pPr algn="l">
-              <a:defRPr sz="441">
+              <a:defRPr sz="756">
                 <a:solidFill>
                   <a:schemeClr val="tx1">
                     <a:tint val="82000"/>
@@ -3405,7 +3821,7 @@
           <a:p>
             <a:fld id="{1B0A7230-9229-4B4E-8CC9-329D15B7627B}" type="datetimeFigureOut">
               <a:rPr lang="en-GB" smtClean="0"/>
-              <a:t>22/01/2026</a:t>
+              <a:t>23/01/2026</a:t>
             </a:fld>
             <a:endParaRPr lang="en-GB"/>
           </a:p>
@@ -3423,8 +3839,8 @@
         </p:nvSpPr>
         <p:spPr>
           <a:xfrm>
-            <a:off x="1907818" y="2335076"/>
-            <a:ext cx="1943814" cy="134133"/>
+            <a:off x="1907818" y="4103673"/>
+            <a:ext cx="1943814" cy="235725"/>
           </a:xfrm>
           <a:prstGeom prst="rect">
             <a:avLst/>
@@ -3434,7 +3850,7 @@
           <a:bodyPr vert="horz" lIns="91440" tIns="45720" rIns="91440" bIns="45720" rtlCol="0" anchor="ctr"/>
           <a:lstStyle>
             <a:lvl1pPr algn="ctr">
-              <a:defRPr sz="441">
+              <a:defRPr sz="756">
                 <a:solidFill>
                   <a:schemeClr val="tx1">
                     <a:tint val="82000"/>
@@ -3460,8 +3876,8 @@
         </p:nvSpPr>
         <p:spPr>
           <a:xfrm>
-            <a:off x="4067612" y="2335076"/>
-            <a:ext cx="1295876" cy="134133"/>
+            <a:off x="4067612" y="4103673"/>
+            <a:ext cx="1295876" cy="235725"/>
           </a:xfrm>
           <a:prstGeom prst="rect">
             <a:avLst/>
@@ -3471,7 +3887,7 @@
           <a:bodyPr vert="horz" lIns="91440" tIns="45720" rIns="91440" bIns="45720" rtlCol="0" anchor="ctr"/>
           <a:lstStyle>
             <a:lvl1pPr algn="r">
-              <a:defRPr sz="441">
+              <a:defRPr sz="756">
                 <a:solidFill>
                   <a:schemeClr val="tx1">
                     <a:tint val="82000"/>
@@ -3492,27 +3908,27 @@
     </p:spTree>
     <p:extLst>
       <p:ext uri="{BB962C8B-B14F-4D97-AF65-F5344CB8AC3E}">
-        <p14:creationId xmlns:p14="http://schemas.microsoft.com/office/powerpoint/2010/main" val="2391288883"/>
+        <p14:creationId xmlns:p14="http://schemas.microsoft.com/office/powerpoint/2010/main" val="314637908"/>
       </p:ext>
     </p:extLst>
   </p:cSld>
   <p:clrMap bg1="lt1" tx1="dk1" bg2="lt2" tx2="dk2" accent1="accent1" accent2="accent2" accent3="accent3" accent4="accent4" accent5="accent5" accent6="accent6" hlink="hlink" folHlink="folHlink"/>
   <p:sldLayoutIdLst>
-    <p:sldLayoutId id="2147483781" r:id="rId1"/>
-    <p:sldLayoutId id="2147483782" r:id="rId2"/>
-    <p:sldLayoutId id="2147483783" r:id="rId3"/>
-    <p:sldLayoutId id="2147483784" r:id="rId4"/>
-    <p:sldLayoutId id="2147483785" r:id="rId5"/>
-    <p:sldLayoutId id="2147483786" r:id="rId6"/>
-    <p:sldLayoutId id="2147483787" r:id="rId7"/>
-    <p:sldLayoutId id="2147483788" r:id="rId8"/>
-    <p:sldLayoutId id="2147483789" r:id="rId9"/>
-    <p:sldLayoutId id="2147483790" r:id="rId10"/>
-    <p:sldLayoutId id="2147483791" r:id="rId11"/>
+    <p:sldLayoutId id="2147483805" r:id="rId1"/>
+    <p:sldLayoutId id="2147483806" r:id="rId2"/>
+    <p:sldLayoutId id="2147483807" r:id="rId3"/>
+    <p:sldLayoutId id="2147483808" r:id="rId4"/>
+    <p:sldLayoutId id="2147483809" r:id="rId5"/>
+    <p:sldLayoutId id="2147483810" r:id="rId6"/>
+    <p:sldLayoutId id="2147483811" r:id="rId7"/>
+    <p:sldLayoutId id="2147483812" r:id="rId8"/>
+    <p:sldLayoutId id="2147483813" r:id="rId9"/>
+    <p:sldLayoutId id="2147483814" r:id="rId10"/>
+    <p:sldLayoutId id="2147483815" r:id="rId11"/>
   </p:sldLayoutIdLst>
   <p:txStyles>
     <p:titleStyle>
-      <a:lvl1pPr algn="l" defTabSz="335951" rtl="0" eaLnBrk="1" latinLnBrk="0" hangingPunct="1">
+      <a:lvl1pPr algn="l" defTabSz="575981" rtl="0" eaLnBrk="1" latinLnBrk="0" hangingPunct="1">
         <a:lnSpc>
           <a:spcPct val="90000"/>
         </a:lnSpc>
@@ -3520,7 +3936,7 @@
           <a:spcPct val="0"/>
         </a:spcBef>
         <a:buNone/>
-        <a:defRPr sz="1617" kern="1200">
+        <a:defRPr sz="2772" kern="1200">
           <a:solidFill>
             <a:schemeClr val="tx1"/>
           </a:solidFill>
@@ -3531,16 +3947,16 @@
       </a:lvl1pPr>
     </p:titleStyle>
     <p:bodyStyle>
-      <a:lvl1pPr marL="83988" indent="-83988" algn="l" defTabSz="335951" rtl="0" eaLnBrk="1" latinLnBrk="0" hangingPunct="1">
+      <a:lvl1pPr marL="143995" indent="-143995" algn="l" defTabSz="575981" rtl="0" eaLnBrk="1" latinLnBrk="0" hangingPunct="1">
         <a:lnSpc>
           <a:spcPct val="90000"/>
         </a:lnSpc>
         <a:spcBef>
-          <a:spcPts val="367"/>
+          <a:spcPts val="630"/>
         </a:spcBef>
         <a:buFont typeface="Arial" panose="020B0604020202020204" pitchFamily="34" charset="0"/>
         <a:buChar char="•"/>
-        <a:defRPr sz="1029" kern="1200">
+        <a:defRPr sz="1764" kern="1200">
           <a:solidFill>
             <a:schemeClr val="tx1"/>
           </a:solidFill>
@@ -3549,16 +3965,16 @@
           <a:cs typeface="+mn-cs"/>
         </a:defRPr>
       </a:lvl1pPr>
-      <a:lvl2pPr marL="251963" indent="-83988" algn="l" defTabSz="335951" rtl="0" eaLnBrk="1" latinLnBrk="0" hangingPunct="1">
+      <a:lvl2pPr marL="431985" indent="-143995" algn="l" defTabSz="575981" rtl="0" eaLnBrk="1" latinLnBrk="0" hangingPunct="1">
         <a:lnSpc>
           <a:spcPct val="90000"/>
         </a:lnSpc>
         <a:spcBef>
-          <a:spcPts val="184"/>
+          <a:spcPts val="315"/>
         </a:spcBef>
         <a:buFont typeface="Arial" panose="020B0604020202020204" pitchFamily="34" charset="0"/>
         <a:buChar char="•"/>
-        <a:defRPr sz="882" kern="1200">
+        <a:defRPr sz="1512" kern="1200">
           <a:solidFill>
             <a:schemeClr val="tx1"/>
           </a:solidFill>
@@ -3567,16 +3983,16 @@
           <a:cs typeface="+mn-cs"/>
         </a:defRPr>
       </a:lvl2pPr>
-      <a:lvl3pPr marL="419938" indent="-83988" algn="l" defTabSz="335951" rtl="0" eaLnBrk="1" latinLnBrk="0" hangingPunct="1">
+      <a:lvl3pPr marL="719976" indent="-143995" algn="l" defTabSz="575981" rtl="0" eaLnBrk="1" latinLnBrk="0" hangingPunct="1">
         <a:lnSpc>
           <a:spcPct val="90000"/>
         </a:lnSpc>
         <a:spcBef>
-          <a:spcPts val="184"/>
+          <a:spcPts val="315"/>
         </a:spcBef>
         <a:buFont typeface="Arial" panose="020B0604020202020204" pitchFamily="34" charset="0"/>
         <a:buChar char="•"/>
-        <a:defRPr sz="735" kern="1200">
+        <a:defRPr sz="1260" kern="1200">
           <a:solidFill>
             <a:schemeClr val="tx1"/>
           </a:solidFill>
@@ -3585,16 +4001,16 @@
           <a:cs typeface="+mn-cs"/>
         </a:defRPr>
       </a:lvl3pPr>
-      <a:lvl4pPr marL="587913" indent="-83988" algn="l" defTabSz="335951" rtl="0" eaLnBrk="1" latinLnBrk="0" hangingPunct="1">
+      <a:lvl4pPr marL="1007966" indent="-143995" algn="l" defTabSz="575981" rtl="0" eaLnBrk="1" latinLnBrk="0" hangingPunct="1">
         <a:lnSpc>
           <a:spcPct val="90000"/>
         </a:lnSpc>
         <a:spcBef>
-          <a:spcPts val="184"/>
+          <a:spcPts val="315"/>
         </a:spcBef>
         <a:buFont typeface="Arial" panose="020B0604020202020204" pitchFamily="34" charset="0"/>
         <a:buChar char="•"/>
-        <a:defRPr sz="661" kern="1200">
+        <a:defRPr sz="1134" kern="1200">
           <a:solidFill>
             <a:schemeClr val="tx1"/>
           </a:solidFill>
@@ -3603,16 +4019,16 @@
           <a:cs typeface="+mn-cs"/>
         </a:defRPr>
       </a:lvl4pPr>
-      <a:lvl5pPr marL="755889" indent="-83988" algn="l" defTabSz="335951" rtl="0" eaLnBrk="1" latinLnBrk="0" hangingPunct="1">
+      <a:lvl5pPr marL="1295956" indent="-143995" algn="l" defTabSz="575981" rtl="0" eaLnBrk="1" latinLnBrk="0" hangingPunct="1">
         <a:lnSpc>
           <a:spcPct val="90000"/>
         </a:lnSpc>
         <a:spcBef>
-          <a:spcPts val="184"/>
+          <a:spcPts val="315"/>
         </a:spcBef>
         <a:buFont typeface="Arial" panose="020B0604020202020204" pitchFamily="34" charset="0"/>
         <a:buChar char="•"/>
-        <a:defRPr sz="661" kern="1200">
+        <a:defRPr sz="1134" kern="1200">
           <a:solidFill>
             <a:schemeClr val="tx1"/>
           </a:solidFill>
@@ -3621,16 +4037,16 @@
           <a:cs typeface="+mn-cs"/>
         </a:defRPr>
       </a:lvl5pPr>
-      <a:lvl6pPr marL="923864" indent="-83988" algn="l" defTabSz="335951" rtl="0" eaLnBrk="1" latinLnBrk="0" hangingPunct="1">
+      <a:lvl6pPr marL="1583947" indent="-143995" algn="l" defTabSz="575981" rtl="0" eaLnBrk="1" latinLnBrk="0" hangingPunct="1">
         <a:lnSpc>
           <a:spcPct val="90000"/>
         </a:lnSpc>
         <a:spcBef>
-          <a:spcPts val="184"/>
+          <a:spcPts val="315"/>
         </a:spcBef>
         <a:buFont typeface="Arial" panose="020B0604020202020204" pitchFamily="34" charset="0"/>
         <a:buChar char="•"/>
-        <a:defRPr sz="661" kern="1200">
+        <a:defRPr sz="1134" kern="1200">
           <a:solidFill>
             <a:schemeClr val="tx1"/>
           </a:solidFill>
@@ -3639,16 +4055,16 @@
           <a:cs typeface="+mn-cs"/>
         </a:defRPr>
       </a:lvl6pPr>
-      <a:lvl7pPr marL="1091839" indent="-83988" algn="l" defTabSz="335951" rtl="0" eaLnBrk="1" latinLnBrk="0" hangingPunct="1">
+      <a:lvl7pPr marL="1871937" indent="-143995" algn="l" defTabSz="575981" rtl="0" eaLnBrk="1" latinLnBrk="0" hangingPunct="1">
         <a:lnSpc>
           <a:spcPct val="90000"/>
         </a:lnSpc>
         <a:spcBef>
-          <a:spcPts val="184"/>
+          <a:spcPts val="315"/>
         </a:spcBef>
         <a:buFont typeface="Arial" panose="020B0604020202020204" pitchFamily="34" charset="0"/>
         <a:buChar char="•"/>
-        <a:defRPr sz="661" kern="1200">
+        <a:defRPr sz="1134" kern="1200">
           <a:solidFill>
             <a:schemeClr val="tx1"/>
           </a:solidFill>
@@ -3657,16 +4073,16 @@
           <a:cs typeface="+mn-cs"/>
         </a:defRPr>
       </a:lvl7pPr>
-      <a:lvl8pPr marL="1259815" indent="-83988" algn="l" defTabSz="335951" rtl="0" eaLnBrk="1" latinLnBrk="0" hangingPunct="1">
+      <a:lvl8pPr marL="2159927" indent="-143995" algn="l" defTabSz="575981" rtl="0" eaLnBrk="1" latinLnBrk="0" hangingPunct="1">
         <a:lnSpc>
           <a:spcPct val="90000"/>
         </a:lnSpc>
         <a:spcBef>
-          <a:spcPts val="184"/>
+          <a:spcPts val="315"/>
         </a:spcBef>
         <a:buFont typeface="Arial" panose="020B0604020202020204" pitchFamily="34" charset="0"/>
         <a:buChar char="•"/>
-        <a:defRPr sz="661" kern="1200">
+        <a:defRPr sz="1134" kern="1200">
           <a:solidFill>
             <a:schemeClr val="tx1"/>
           </a:solidFill>
@@ -3675,16 +4091,16 @@
           <a:cs typeface="+mn-cs"/>
         </a:defRPr>
       </a:lvl8pPr>
-      <a:lvl9pPr marL="1427790" indent="-83988" algn="l" defTabSz="335951" rtl="0" eaLnBrk="1" latinLnBrk="0" hangingPunct="1">
+      <a:lvl9pPr marL="2447917" indent="-143995" algn="l" defTabSz="575981" rtl="0" eaLnBrk="1" latinLnBrk="0" hangingPunct="1">
         <a:lnSpc>
           <a:spcPct val="90000"/>
         </a:lnSpc>
         <a:spcBef>
-          <a:spcPts val="184"/>
+          <a:spcPts val="315"/>
         </a:spcBef>
         <a:buFont typeface="Arial" panose="020B0604020202020204" pitchFamily="34" charset="0"/>
         <a:buChar char="•"/>
-        <a:defRPr sz="661" kern="1200">
+        <a:defRPr sz="1134" kern="1200">
           <a:solidFill>
             <a:schemeClr val="tx1"/>
           </a:solidFill>
@@ -3698,8 +4114,8 @@
       <a:defPPr>
         <a:defRPr lang="en-US"/>
       </a:defPPr>
-      <a:lvl1pPr marL="0" algn="l" defTabSz="335951" rtl="0" eaLnBrk="1" latinLnBrk="0" hangingPunct="1">
-        <a:defRPr sz="661" kern="1200">
+      <a:lvl1pPr marL="0" algn="l" defTabSz="575981" rtl="0" eaLnBrk="1" latinLnBrk="0" hangingPunct="1">
+        <a:defRPr sz="1134" kern="1200">
           <a:solidFill>
             <a:schemeClr val="tx1"/>
           </a:solidFill>
@@ -3708,8 +4124,8 @@
           <a:cs typeface="+mn-cs"/>
         </a:defRPr>
       </a:lvl1pPr>
-      <a:lvl2pPr marL="167975" algn="l" defTabSz="335951" rtl="0" eaLnBrk="1" latinLnBrk="0" hangingPunct="1">
-        <a:defRPr sz="661" kern="1200">
+      <a:lvl2pPr marL="287990" algn="l" defTabSz="575981" rtl="0" eaLnBrk="1" latinLnBrk="0" hangingPunct="1">
+        <a:defRPr sz="1134" kern="1200">
           <a:solidFill>
             <a:schemeClr val="tx1"/>
           </a:solidFill>
@@ -3718,8 +4134,8 @@
           <a:cs typeface="+mn-cs"/>
         </a:defRPr>
       </a:lvl2pPr>
-      <a:lvl3pPr marL="335951" algn="l" defTabSz="335951" rtl="0" eaLnBrk="1" latinLnBrk="0" hangingPunct="1">
-        <a:defRPr sz="661" kern="1200">
+      <a:lvl3pPr marL="575981" algn="l" defTabSz="575981" rtl="0" eaLnBrk="1" latinLnBrk="0" hangingPunct="1">
+        <a:defRPr sz="1134" kern="1200">
           <a:solidFill>
             <a:schemeClr val="tx1"/>
           </a:solidFill>
@@ -3728,8 +4144,8 @@
           <a:cs typeface="+mn-cs"/>
         </a:defRPr>
       </a:lvl3pPr>
-      <a:lvl4pPr marL="503926" algn="l" defTabSz="335951" rtl="0" eaLnBrk="1" latinLnBrk="0" hangingPunct="1">
-        <a:defRPr sz="661" kern="1200">
+      <a:lvl4pPr marL="863971" algn="l" defTabSz="575981" rtl="0" eaLnBrk="1" latinLnBrk="0" hangingPunct="1">
+        <a:defRPr sz="1134" kern="1200">
           <a:solidFill>
             <a:schemeClr val="tx1"/>
           </a:solidFill>
@@ -3738,8 +4154,8 @@
           <a:cs typeface="+mn-cs"/>
         </a:defRPr>
       </a:lvl4pPr>
-      <a:lvl5pPr marL="671901" algn="l" defTabSz="335951" rtl="0" eaLnBrk="1" latinLnBrk="0" hangingPunct="1">
-        <a:defRPr sz="661" kern="1200">
+      <a:lvl5pPr marL="1151961" algn="l" defTabSz="575981" rtl="0" eaLnBrk="1" latinLnBrk="0" hangingPunct="1">
+        <a:defRPr sz="1134" kern="1200">
           <a:solidFill>
             <a:schemeClr val="tx1"/>
           </a:solidFill>
@@ -3748,8 +4164,8 @@
           <a:cs typeface="+mn-cs"/>
         </a:defRPr>
       </a:lvl5pPr>
-      <a:lvl6pPr marL="839876" algn="l" defTabSz="335951" rtl="0" eaLnBrk="1" latinLnBrk="0" hangingPunct="1">
-        <a:defRPr sz="661" kern="1200">
+      <a:lvl6pPr marL="1439951" algn="l" defTabSz="575981" rtl="0" eaLnBrk="1" latinLnBrk="0" hangingPunct="1">
+        <a:defRPr sz="1134" kern="1200">
           <a:solidFill>
             <a:schemeClr val="tx1"/>
           </a:solidFill>
@@ -3758,8 +4174,8 @@
           <a:cs typeface="+mn-cs"/>
         </a:defRPr>
       </a:lvl6pPr>
-      <a:lvl7pPr marL="1007852" algn="l" defTabSz="335951" rtl="0" eaLnBrk="1" latinLnBrk="0" hangingPunct="1">
-        <a:defRPr sz="661" kern="1200">
+      <a:lvl7pPr marL="1727942" algn="l" defTabSz="575981" rtl="0" eaLnBrk="1" latinLnBrk="0" hangingPunct="1">
+        <a:defRPr sz="1134" kern="1200">
           <a:solidFill>
             <a:schemeClr val="tx1"/>
           </a:solidFill>
@@ -3768,8 +4184,8 @@
           <a:cs typeface="+mn-cs"/>
         </a:defRPr>
       </a:lvl7pPr>
-      <a:lvl8pPr marL="1175827" algn="l" defTabSz="335951" rtl="0" eaLnBrk="1" latinLnBrk="0" hangingPunct="1">
-        <a:defRPr sz="661" kern="1200">
+      <a:lvl8pPr marL="2015932" algn="l" defTabSz="575981" rtl="0" eaLnBrk="1" latinLnBrk="0" hangingPunct="1">
+        <a:defRPr sz="1134" kern="1200">
           <a:solidFill>
             <a:schemeClr val="tx1"/>
           </a:solidFill>
@@ -3778,8 +4194,8 @@
           <a:cs typeface="+mn-cs"/>
         </a:defRPr>
       </a:lvl8pPr>
-      <a:lvl9pPr marL="1343802" algn="l" defTabSz="335951" rtl="0" eaLnBrk="1" latinLnBrk="0" hangingPunct="1">
-        <a:defRPr sz="661" kern="1200">
+      <a:lvl9pPr marL="2303922" algn="l" defTabSz="575981" rtl="0" eaLnBrk="1" latinLnBrk="0" hangingPunct="1">
+        <a:defRPr sz="1134" kern="1200">
           <a:solidFill>
             <a:schemeClr val="tx1"/>
           </a:solidFill>
@@ -3810,9 +4226,39 @@
           <a:chExt cx="0" cy="0"/>
         </a:xfrm>
       </p:grpSpPr>
+      <p:pic>
+        <p:nvPicPr>
+          <p:cNvPr id="68" name="Picture 67">
+            <a:extLst>
+              <a:ext uri="{FF2B5EF4-FFF2-40B4-BE49-F238E27FC236}">
+                <a16:creationId xmlns:a16="http://schemas.microsoft.com/office/drawing/2014/main" id="{F45F7555-78D7-C8CF-FA3E-833AF9A9DC4F}"/>
+              </a:ext>
+            </a:extLst>
+          </p:cNvPr>
+          <p:cNvPicPr>
+            <a:picLocks noChangeAspect="1"/>
+          </p:cNvPicPr>
+          <p:nvPr/>
+        </p:nvPicPr>
+        <p:blipFill>
+          <a:blip r:embed="rId2"/>
+          <a:stretch>
+            <a:fillRect/>
+          </a:stretch>
+        </p:blipFill>
+        <p:spPr>
+          <a:xfrm>
+            <a:off x="518514" y="962714"/>
+            <a:ext cx="2060879" cy="1119805"/>
+          </a:xfrm>
+          <a:prstGeom prst="rect">
+            <a:avLst/>
+          </a:prstGeom>
+        </p:spPr>
+      </p:pic>
       <p:sp>
         <p:nvSpPr>
-          <p:cNvPr id="114" name="Freeform: Shape 113">
+          <p:cNvPr id="69" name="Freeform: Shape 68">
             <a:extLst>
               <a:ext uri="{FF2B5EF4-FFF2-40B4-BE49-F238E27FC236}">
                 <a16:creationId xmlns:a16="http://schemas.microsoft.com/office/drawing/2014/main" id="{863D7830-3EC5-1488-4779-4B842624939D}"/>
@@ -5205,7 +5651,7 @@
       </p:sp>
       <p:cxnSp>
         <p:nvCxnSpPr>
-          <p:cNvPr id="115" name="Straight Connector 114">
+          <p:cNvPr id="70" name="Straight Connector 69">
             <a:extLst>
               <a:ext uri="{FF2B5EF4-FFF2-40B4-BE49-F238E27FC236}">
                 <a16:creationId xmlns:a16="http://schemas.microsoft.com/office/drawing/2014/main" id="{A9EAFB7D-EF2C-3FE3-1553-F2A5789D0B03}"/>
@@ -5252,7 +5698,7 @@
       </p:cxnSp>
       <p:cxnSp>
         <p:nvCxnSpPr>
-          <p:cNvPr id="116" name="Straight Connector 115">
+          <p:cNvPr id="71" name="Straight Connector 70">
             <a:extLst>
               <a:ext uri="{FF2B5EF4-FFF2-40B4-BE49-F238E27FC236}">
                 <a16:creationId xmlns:a16="http://schemas.microsoft.com/office/drawing/2014/main" id="{E285F2A1-75BD-C1B8-AE9A-EABFD7341599}"/>
@@ -5299,7 +5745,7 @@
       </p:cxnSp>
       <p:cxnSp>
         <p:nvCxnSpPr>
-          <p:cNvPr id="117" name="Straight Arrow Connector 116">
+          <p:cNvPr id="72" name="Straight Arrow Connector 71">
             <a:extLst>
               <a:ext uri="{FF2B5EF4-FFF2-40B4-BE49-F238E27FC236}">
                 <a16:creationId xmlns:a16="http://schemas.microsoft.com/office/drawing/2014/main" id="{5DDB82E1-2293-6864-7C4C-860BB6D52449}"/>
@@ -5346,7 +5792,7 @@
       </p:cxnSp>
       <p:cxnSp>
         <p:nvCxnSpPr>
-          <p:cNvPr id="118" name="Straight Arrow Connector 117">
+          <p:cNvPr id="73" name="Straight Arrow Connector 72">
             <a:extLst>
               <a:ext uri="{FF2B5EF4-FFF2-40B4-BE49-F238E27FC236}">
                 <a16:creationId xmlns:a16="http://schemas.microsoft.com/office/drawing/2014/main" id="{9C8F36A9-FFBF-D2AF-D86B-DB32A664D134}"/>
@@ -5393,7 +5839,7 @@
       </p:cxnSp>
       <p:sp>
         <p:nvSpPr>
-          <p:cNvPr id="119" name="TextBox 118">
+          <p:cNvPr id="74" name="TextBox 73">
             <a:extLst>
               <a:ext uri="{FF2B5EF4-FFF2-40B4-BE49-F238E27FC236}">
                 <a16:creationId xmlns:a16="http://schemas.microsoft.com/office/drawing/2014/main" id="{F4E1EB47-FB49-B221-8F40-6FAAC8188E34}"/>
@@ -5452,7 +5898,7 @@
       </p:sp>
       <p:sp>
         <p:nvSpPr>
-          <p:cNvPr id="120" name="Freeform: Shape 119">
+          <p:cNvPr id="75" name="Freeform: Shape 74">
             <a:extLst>
               <a:ext uri="{FF2B5EF4-FFF2-40B4-BE49-F238E27FC236}">
                 <a16:creationId xmlns:a16="http://schemas.microsoft.com/office/drawing/2014/main" id="{ADEEF2B1-EBC8-9F1F-6B1F-DD1E6A4ADDB0}"/>
@@ -8101,7 +8547,7 @@
               </a:path>
             </a:pathLst>
           </a:custGeom>
-          <a:pattFill prst="wdDnDiag">
+          <a:pattFill prst="wdUpDiag">
             <a:fgClr>
               <a:srgbClr val="21857A"/>
             </a:fgClr>
@@ -8143,7 +8589,7 @@
       </p:sp>
       <p:sp>
         <p:nvSpPr>
-          <p:cNvPr id="121" name="Freeform: Shape 120">
+          <p:cNvPr id="76" name="Freeform: Shape 75">
             <a:extLst>
               <a:ext uri="{FF2B5EF4-FFF2-40B4-BE49-F238E27FC236}">
                 <a16:creationId xmlns:a16="http://schemas.microsoft.com/office/drawing/2014/main" id="{CDB02FB9-7686-55B5-2237-CE34FE7138F4}"/>
@@ -8579,7 +9025,7 @@
       </p:sp>
       <p:cxnSp>
         <p:nvCxnSpPr>
-          <p:cNvPr id="122" name="Straight Arrow Connector 121">
+          <p:cNvPr id="77" name="Straight Arrow Connector 76">
             <a:extLst>
               <a:ext uri="{FF2B5EF4-FFF2-40B4-BE49-F238E27FC236}">
                 <a16:creationId xmlns:a16="http://schemas.microsoft.com/office/drawing/2014/main" id="{98EEF7E7-0C5F-BA49-C209-AFA93EACC957}"/>
@@ -8626,7 +9072,7 @@
       </p:cxnSp>
       <p:sp>
         <p:nvSpPr>
-          <p:cNvPr id="123" name="Freeform: Shape 122">
+          <p:cNvPr id="78" name="Freeform: Shape 77">
             <a:extLst>
               <a:ext uri="{FF2B5EF4-FFF2-40B4-BE49-F238E27FC236}">
                 <a16:creationId xmlns:a16="http://schemas.microsoft.com/office/drawing/2014/main" id="{F1CE41FF-7B22-BB87-5437-9C5A6D9C40EA}"/>
@@ -9726,7 +10172,7 @@
       </p:sp>
       <p:sp>
         <p:nvSpPr>
-          <p:cNvPr id="124" name="Freeform: Shape 123">
+          <p:cNvPr id="79" name="Freeform: Shape 78">
             <a:extLst>
               <a:ext uri="{FF2B5EF4-FFF2-40B4-BE49-F238E27FC236}">
                 <a16:creationId xmlns:a16="http://schemas.microsoft.com/office/drawing/2014/main" id="{3CDA144B-1F01-F0CC-A493-5631BE7BE96B}"/>
@@ -11557,7 +12003,7 @@
       </p:sp>
       <p:sp>
         <p:nvSpPr>
-          <p:cNvPr id="125" name="Freeform: Shape 124">
+          <p:cNvPr id="80" name="Freeform: Shape 79">
             <a:extLst>
               <a:ext uri="{FF2B5EF4-FFF2-40B4-BE49-F238E27FC236}">
                 <a16:creationId xmlns:a16="http://schemas.microsoft.com/office/drawing/2014/main" id="{9D4C28E0-97DE-3DC8-9344-F610BE62157D}"/>
@@ -14028,7 +14474,7 @@
       </p:sp>
       <p:cxnSp>
         <p:nvCxnSpPr>
-          <p:cNvPr id="126" name="Straight Arrow Connector 125">
+          <p:cNvPr id="81" name="Straight Arrow Connector 80">
             <a:extLst>
               <a:ext uri="{FF2B5EF4-FFF2-40B4-BE49-F238E27FC236}">
                 <a16:creationId xmlns:a16="http://schemas.microsoft.com/office/drawing/2014/main" id="{E3E411FB-33CC-5F34-656E-94560D185092}"/>
@@ -14075,7 +14521,7 @@
       </p:cxnSp>
       <p:sp>
         <p:nvSpPr>
-          <p:cNvPr id="127" name="TextBox 126">
+          <p:cNvPr id="82" name="TextBox 81">
             <a:extLst>
               <a:ext uri="{FF2B5EF4-FFF2-40B4-BE49-F238E27FC236}">
                 <a16:creationId xmlns:a16="http://schemas.microsoft.com/office/drawing/2014/main" id="{871F6875-B35B-38C5-3426-33D516CADAB5}"/>
@@ -14124,7 +14570,7 @@
       </p:sp>
       <p:sp>
         <p:nvSpPr>
-          <p:cNvPr id="128" name="TextBox 127">
+          <p:cNvPr id="83" name="TextBox 82">
             <a:extLst>
               <a:ext uri="{FF2B5EF4-FFF2-40B4-BE49-F238E27FC236}">
                 <a16:creationId xmlns:a16="http://schemas.microsoft.com/office/drawing/2014/main" id="{843DCFB4-D832-CE14-33FD-22FE10682A05}"/>
@@ -14173,7 +14619,7 @@
       </p:sp>
       <p:sp>
         <p:nvSpPr>
-          <p:cNvPr id="129" name="TextBox 128">
+          <p:cNvPr id="84" name="TextBox 83">
             <a:extLst>
               <a:ext uri="{FF2B5EF4-FFF2-40B4-BE49-F238E27FC236}">
                 <a16:creationId xmlns:a16="http://schemas.microsoft.com/office/drawing/2014/main" id="{1ACBC9A4-96CE-2145-4C13-43843EED1EEE}"/>
@@ -14222,7 +14668,7 @@
       </p:sp>
       <p:sp>
         <p:nvSpPr>
-          <p:cNvPr id="130" name="TextBox 129">
+          <p:cNvPr id="85" name="TextBox 84">
             <a:extLst>
               <a:ext uri="{FF2B5EF4-FFF2-40B4-BE49-F238E27FC236}">
                 <a16:creationId xmlns:a16="http://schemas.microsoft.com/office/drawing/2014/main" id="{5CCEEB50-0EB3-291D-2911-B86403C69D4E}"/>
@@ -14271,7 +14717,7 @@
       </p:sp>
       <p:cxnSp>
         <p:nvCxnSpPr>
-          <p:cNvPr id="131" name="Straight Connector 130">
+          <p:cNvPr id="86" name="Straight Connector 85">
             <a:extLst>
               <a:ext uri="{FF2B5EF4-FFF2-40B4-BE49-F238E27FC236}">
                 <a16:creationId xmlns:a16="http://schemas.microsoft.com/office/drawing/2014/main" id="{A0143ED4-4C89-1348-C278-56520894994E}"/>
@@ -14317,7 +14763,7 @@
       </p:cxnSp>
       <p:cxnSp>
         <p:nvCxnSpPr>
-          <p:cNvPr id="132" name="Straight Connector 131">
+          <p:cNvPr id="87" name="Straight Connector 86">
             <a:extLst>
               <a:ext uri="{FF2B5EF4-FFF2-40B4-BE49-F238E27FC236}">
                 <a16:creationId xmlns:a16="http://schemas.microsoft.com/office/drawing/2014/main" id="{F722787C-8461-E4FE-8414-D479477597C4}"/>
@@ -14363,7 +14809,7 @@
       </p:cxnSp>
       <p:sp>
         <p:nvSpPr>
-          <p:cNvPr id="133" name="TextBox 132">
+          <p:cNvPr id="88" name="TextBox 87">
             <a:extLst>
               <a:ext uri="{FF2B5EF4-FFF2-40B4-BE49-F238E27FC236}">
                 <a16:creationId xmlns:a16="http://schemas.microsoft.com/office/drawing/2014/main" id="{DD906E7D-FF64-09FE-65EF-837BDD47046A}"/>
@@ -14415,7 +14861,7 @@
       </p:sp>
       <p:sp>
         <p:nvSpPr>
-          <p:cNvPr id="134" name="TextBox 133">
+          <p:cNvPr id="89" name="TextBox 88">
             <a:extLst>
               <a:ext uri="{FF2B5EF4-FFF2-40B4-BE49-F238E27FC236}">
                 <a16:creationId xmlns:a16="http://schemas.microsoft.com/office/drawing/2014/main" id="{CDF5D99F-239B-7286-E705-43476984C1FD}"/>
@@ -14457,7 +14903,7 @@
       </p:sp>
       <p:sp>
         <p:nvSpPr>
-          <p:cNvPr id="135" name="TextBox 134">
+          <p:cNvPr id="90" name="TextBox 89">
             <a:extLst>
               <a:ext uri="{FF2B5EF4-FFF2-40B4-BE49-F238E27FC236}">
                 <a16:creationId xmlns:a16="http://schemas.microsoft.com/office/drawing/2014/main" id="{A09387BF-360E-1373-B4E2-484CDF5B6943}"/>
@@ -14509,7 +14955,7 @@
       </p:sp>
       <p:sp>
         <p:nvSpPr>
-          <p:cNvPr id="136" name="TextBox 135">
+          <p:cNvPr id="91" name="TextBox 90">
             <a:extLst>
               <a:ext uri="{FF2B5EF4-FFF2-40B4-BE49-F238E27FC236}">
                 <a16:creationId xmlns:a16="http://schemas.microsoft.com/office/drawing/2014/main" id="{FEE84F7D-562E-3E17-3F19-517232627412}"/>
@@ -14551,7 +14997,7 @@
       </p:sp>
       <p:sp>
         <p:nvSpPr>
-          <p:cNvPr id="137" name="TextBox 136">
+          <p:cNvPr id="92" name="TextBox 91">
             <a:extLst>
               <a:ext uri="{FF2B5EF4-FFF2-40B4-BE49-F238E27FC236}">
                 <a16:creationId xmlns:a16="http://schemas.microsoft.com/office/drawing/2014/main" id="{F3106249-1C45-1C12-2453-07133FF1CD86}"/>
@@ -14593,7 +15039,7 @@
       </p:sp>
       <p:sp>
         <p:nvSpPr>
-          <p:cNvPr id="138" name="TextBox 137">
+          <p:cNvPr id="93" name="TextBox 92">
             <a:extLst>
               <a:ext uri="{FF2B5EF4-FFF2-40B4-BE49-F238E27FC236}">
                 <a16:creationId xmlns:a16="http://schemas.microsoft.com/office/drawing/2014/main" id="{E3F5F678-30B9-E5A6-EDA8-349820A25D9E}"/>
@@ -14635,7 +15081,7 @@
       </p:sp>
       <p:sp>
         <p:nvSpPr>
-          <p:cNvPr id="139" name="Rectangle 138">
+          <p:cNvPr id="94" name="Rectangle 93">
             <a:extLst>
               <a:ext uri="{FF2B5EF4-FFF2-40B4-BE49-F238E27FC236}">
                 <a16:creationId xmlns:a16="http://schemas.microsoft.com/office/drawing/2014/main" id="{2D87FE8A-4BD4-D2C0-4981-4C00E52C4C21}"/>
@@ -14699,7 +15145,7 @@
       </p:sp>
       <p:sp>
         <p:nvSpPr>
-          <p:cNvPr id="140" name="Rectangle 139">
+          <p:cNvPr id="95" name="Rectangle 94">
             <a:extLst>
               <a:ext uri="{FF2B5EF4-FFF2-40B4-BE49-F238E27FC236}">
                 <a16:creationId xmlns:a16="http://schemas.microsoft.com/office/drawing/2014/main" id="{65533EAA-5F83-EA70-6747-5F625123CB00}"/>
@@ -14760,7 +15206,7 @@
       </p:sp>
       <p:sp>
         <p:nvSpPr>
-          <p:cNvPr id="141" name="Rectangle 140">
+          <p:cNvPr id="96" name="Rectangle 95">
             <a:extLst>
               <a:ext uri="{FF2B5EF4-FFF2-40B4-BE49-F238E27FC236}">
                 <a16:creationId xmlns:a16="http://schemas.microsoft.com/office/drawing/2014/main" id="{545E5C43-F926-13EA-70BE-CA710E33D019}"/>
@@ -14821,7 +15267,7 @@
       </p:sp>
       <p:sp>
         <p:nvSpPr>
-          <p:cNvPr id="142" name="Rectangle 141">
+          <p:cNvPr id="97" name="Rectangle 96">
             <a:extLst>
               <a:ext uri="{FF2B5EF4-FFF2-40B4-BE49-F238E27FC236}">
                 <a16:creationId xmlns:a16="http://schemas.microsoft.com/office/drawing/2014/main" id="{4ABA71F5-F7CE-E653-5451-1F27E1EA51A4}"/>
@@ -14839,7 +15285,7 @@
           <a:prstGeom prst="rect">
             <a:avLst/>
           </a:prstGeom>
-          <a:pattFill prst="wdDnDiag">
+          <a:pattFill prst="wdUpDiag">
             <a:fgClr>
               <a:srgbClr val="21857A"/>
             </a:fgClr>
@@ -14883,39 +15329,9 @@
           </a:p>
         </p:txBody>
       </p:sp>
-      <p:pic>
-        <p:nvPicPr>
-          <p:cNvPr id="143" name="Picture 142">
-            <a:extLst>
-              <a:ext uri="{FF2B5EF4-FFF2-40B4-BE49-F238E27FC236}">
-                <a16:creationId xmlns:a16="http://schemas.microsoft.com/office/drawing/2014/main" id="{B4B20B6B-3DAA-796C-8EA6-D7D94A189AD2}"/>
-              </a:ext>
-            </a:extLst>
-          </p:cNvPr>
-          <p:cNvPicPr>
-            <a:picLocks noChangeAspect="1"/>
-          </p:cNvPicPr>
-          <p:nvPr/>
-        </p:nvPicPr>
-        <p:blipFill>
-          <a:blip r:embed="rId2"/>
-          <a:stretch>
-            <a:fillRect/>
-          </a:stretch>
-        </p:blipFill>
-        <p:spPr>
-          <a:xfrm>
-            <a:off x="516369" y="980065"/>
-            <a:ext cx="1987063" cy="1079696"/>
-          </a:xfrm>
-          <a:prstGeom prst="rect">
-            <a:avLst/>
-          </a:prstGeom>
-        </p:spPr>
-      </p:pic>
       <p:sp>
         <p:nvSpPr>
-          <p:cNvPr id="144" name="TextBox 143">
+          <p:cNvPr id="98" name="TextBox 97">
             <a:extLst>
               <a:ext uri="{FF2B5EF4-FFF2-40B4-BE49-F238E27FC236}">
                 <a16:creationId xmlns:a16="http://schemas.microsoft.com/office/drawing/2014/main" id="{D0B60395-29A9-5583-BABB-33B236329A61}"/>
@@ -14960,7 +15376,7 @@
       </p:sp>
       <p:sp>
         <p:nvSpPr>
-          <p:cNvPr id="145" name="TextBox 144">
+          <p:cNvPr id="99" name="TextBox 98">
             <a:extLst>
               <a:ext uri="{FF2B5EF4-FFF2-40B4-BE49-F238E27FC236}">
                 <a16:creationId xmlns:a16="http://schemas.microsoft.com/office/drawing/2014/main" id="{88FD4609-03C7-48B1-EA84-375FFFEDBE06}"/>
@@ -15019,7 +15435,7 @@
       </p:sp>
       <p:sp>
         <p:nvSpPr>
-          <p:cNvPr id="146" name="TextBox 145">
+          <p:cNvPr id="100" name="TextBox 99">
             <a:extLst>
               <a:ext uri="{FF2B5EF4-FFF2-40B4-BE49-F238E27FC236}">
                 <a16:creationId xmlns:a16="http://schemas.microsoft.com/office/drawing/2014/main" id="{4C39D33D-2B26-F2D6-F8F4-09E6518093E9}"/>
@@ -15099,7 +15515,7 @@
       </p:sp>
       <p:sp>
         <p:nvSpPr>
-          <p:cNvPr id="147" name="TextBox 146">
+          <p:cNvPr id="101" name="TextBox 100">
             <a:extLst>
               <a:ext uri="{FF2B5EF4-FFF2-40B4-BE49-F238E27FC236}">
                 <a16:creationId xmlns:a16="http://schemas.microsoft.com/office/drawing/2014/main" id="{D4A499F2-3420-098E-60B9-2B0BAC6336D7}"/>
@@ -15144,7 +15560,7 @@
       </p:sp>
       <p:sp>
         <p:nvSpPr>
-          <p:cNvPr id="148" name="TextBox 147">
+          <p:cNvPr id="102" name="TextBox 101">
             <a:extLst>
               <a:ext uri="{FF2B5EF4-FFF2-40B4-BE49-F238E27FC236}">
                 <a16:creationId xmlns:a16="http://schemas.microsoft.com/office/drawing/2014/main" id="{886A253C-800A-4473-19A4-5EC96B3D6DA8}"/>
@@ -15189,7 +15605,7 @@
       </p:sp>
       <p:sp>
         <p:nvSpPr>
-          <p:cNvPr id="149" name="TextBox 148">
+          <p:cNvPr id="103" name="TextBox 102">
             <a:extLst>
               <a:ext uri="{FF2B5EF4-FFF2-40B4-BE49-F238E27FC236}">
                 <a16:creationId xmlns:a16="http://schemas.microsoft.com/office/drawing/2014/main" id="{31526C8F-65EA-4AE2-A6F7-E27D64A802EA}"/>
@@ -15234,7 +15650,7 @@
       </p:sp>
       <p:sp>
         <p:nvSpPr>
-          <p:cNvPr id="150" name="TextBox 149">
+          <p:cNvPr id="104" name="TextBox 103">
             <a:extLst>
               <a:ext uri="{FF2B5EF4-FFF2-40B4-BE49-F238E27FC236}">
                 <a16:creationId xmlns:a16="http://schemas.microsoft.com/office/drawing/2014/main" id="{2806A400-C100-A7CD-C682-9F752EF41C58}"/>
@@ -15279,7 +15695,7 @@
       </p:sp>
       <p:cxnSp>
         <p:nvCxnSpPr>
-          <p:cNvPr id="151" name="Straight Connector 150">
+          <p:cNvPr id="105" name="Straight Connector 104">
             <a:extLst>
               <a:ext uri="{FF2B5EF4-FFF2-40B4-BE49-F238E27FC236}">
                 <a16:creationId xmlns:a16="http://schemas.microsoft.com/office/drawing/2014/main" id="{3E482B56-9FB4-F1B3-4505-6BC8857291E6}"/>
@@ -15323,7 +15739,7 @@
       </p:cxnSp>
       <p:sp>
         <p:nvSpPr>
-          <p:cNvPr id="152" name="TextBox 151">
+          <p:cNvPr id="106" name="TextBox 105">
             <a:extLst>
               <a:ext uri="{FF2B5EF4-FFF2-40B4-BE49-F238E27FC236}">
                 <a16:creationId xmlns:a16="http://schemas.microsoft.com/office/drawing/2014/main" id="{1B78CC36-883D-5957-AD5C-423198EA1845}"/>
@@ -15392,7 +15808,7 @@
       </p:sp>
       <p:sp>
         <p:nvSpPr>
-          <p:cNvPr id="153" name="TextBox 152">
+          <p:cNvPr id="107" name="TextBox 106">
             <a:extLst>
               <a:ext uri="{FF2B5EF4-FFF2-40B4-BE49-F238E27FC236}">
                 <a16:creationId xmlns:a16="http://schemas.microsoft.com/office/drawing/2014/main" id="{E1F6673A-1B0C-E424-8F99-86B139BD4918}"/>
@@ -15463,7 +15879,7 @@
       </p:sp>
       <p:sp>
         <p:nvSpPr>
-          <p:cNvPr id="154" name="TextBox 153">
+          <p:cNvPr id="108" name="TextBox 107">
             <a:extLst>
               <a:ext uri="{FF2B5EF4-FFF2-40B4-BE49-F238E27FC236}">
                 <a16:creationId xmlns:a16="http://schemas.microsoft.com/office/drawing/2014/main" id="{7160EB10-8701-2F92-B2E3-BD9975B33EAB}"/>
@@ -15543,7 +15959,7 @@
       </p:sp>
       <p:sp>
         <p:nvSpPr>
-          <p:cNvPr id="155" name="TextBox 154">
+          <p:cNvPr id="109" name="TextBox 108">
             <a:extLst>
               <a:ext uri="{FF2B5EF4-FFF2-40B4-BE49-F238E27FC236}">
                 <a16:creationId xmlns:a16="http://schemas.microsoft.com/office/drawing/2014/main" id="{C700B7F9-A72E-559F-D17A-BFCCF191350D}"/>
@@ -15588,7 +16004,7 @@
       </p:sp>
       <p:sp>
         <p:nvSpPr>
-          <p:cNvPr id="156" name="Rectangle 155">
+          <p:cNvPr id="110" name="Rectangle 109">
             <a:extLst>
               <a:ext uri="{FF2B5EF4-FFF2-40B4-BE49-F238E27FC236}">
                 <a16:creationId xmlns:a16="http://schemas.microsoft.com/office/drawing/2014/main" id="{BA6B5728-94FF-1C7C-CD97-4D776F6436FF}"/>
@@ -15641,7 +16057,7 @@
       </p:sp>
       <p:sp>
         <p:nvSpPr>
-          <p:cNvPr id="157" name="TextBox 156">
+          <p:cNvPr id="111" name="TextBox 110">
             <a:extLst>
               <a:ext uri="{FF2B5EF4-FFF2-40B4-BE49-F238E27FC236}">
                 <a16:creationId xmlns:a16="http://schemas.microsoft.com/office/drawing/2014/main" id="{BE8CA2C2-9A67-A315-55CF-D3B76C5B4ABF}"/>
@@ -15686,7 +16102,7 @@
       </p:sp>
       <p:sp>
         <p:nvSpPr>
-          <p:cNvPr id="158" name="TextBox 157">
+          <p:cNvPr id="112" name="TextBox 111">
             <a:extLst>
               <a:ext uri="{FF2B5EF4-FFF2-40B4-BE49-F238E27FC236}">
                 <a16:creationId xmlns:a16="http://schemas.microsoft.com/office/drawing/2014/main" id="{16D7E8D5-094D-0801-2477-66BD27467E33}"/>
@@ -15731,7 +16147,7 @@
       </p:sp>
       <p:sp>
         <p:nvSpPr>
-          <p:cNvPr id="159" name="TextBox 158">
+          <p:cNvPr id="113" name="TextBox 112">
             <a:extLst>
               <a:ext uri="{FF2B5EF4-FFF2-40B4-BE49-F238E27FC236}">
                 <a16:creationId xmlns:a16="http://schemas.microsoft.com/office/drawing/2014/main" id="{5E7D516C-6098-CA78-A68A-A60E91A03B8B}"/>
@@ -15776,7 +16192,7 @@
       </p:sp>
       <p:cxnSp>
         <p:nvCxnSpPr>
-          <p:cNvPr id="160" name="Straight Arrow Connector 159">
+          <p:cNvPr id="165" name="Straight Arrow Connector 164">
             <a:extLst>
               <a:ext uri="{FF2B5EF4-FFF2-40B4-BE49-F238E27FC236}">
                 <a16:creationId xmlns:a16="http://schemas.microsoft.com/office/drawing/2014/main" id="{9F83BDF9-60EC-1D45-016B-A09DF554F68E}"/>
@@ -15823,7 +16239,7 @@
       </p:cxnSp>
       <p:sp>
         <p:nvSpPr>
-          <p:cNvPr id="161" name="Oval 160">
+          <p:cNvPr id="166" name="Oval 165">
             <a:extLst>
               <a:ext uri="{FF2B5EF4-FFF2-40B4-BE49-F238E27FC236}">
                 <a16:creationId xmlns:a16="http://schemas.microsoft.com/office/drawing/2014/main" id="{19C06D92-10F2-6629-738B-329DDCC22607}"/>
@@ -15878,7 +16294,7 @@
       </p:sp>
       <p:sp>
         <p:nvSpPr>
-          <p:cNvPr id="162" name="TextBox 161">
+          <p:cNvPr id="167" name="TextBox 166">
             <a:extLst>
               <a:ext uri="{FF2B5EF4-FFF2-40B4-BE49-F238E27FC236}">
                 <a16:creationId xmlns:a16="http://schemas.microsoft.com/office/drawing/2014/main" id="{8C2CF4A1-967C-6891-8D3E-E404ED5D4E82}"/>
@@ -15922,7 +16338,7 @@
       </p:sp>
       <p:sp>
         <p:nvSpPr>
-          <p:cNvPr id="163" name="TextBox 162">
+          <p:cNvPr id="168" name="TextBox 167">
             <a:extLst>
               <a:ext uri="{FF2B5EF4-FFF2-40B4-BE49-F238E27FC236}">
                 <a16:creationId xmlns:a16="http://schemas.microsoft.com/office/drawing/2014/main" id="{748BB081-753E-2804-7F05-2F111730D61F}"/>
@@ -15966,7 +16382,7 @@
       </p:sp>
       <p:cxnSp>
         <p:nvCxnSpPr>
-          <p:cNvPr id="164" name="Straight Connector 163">
+          <p:cNvPr id="169" name="Straight Connector 168">
             <a:extLst>
               <a:ext uri="{FF2B5EF4-FFF2-40B4-BE49-F238E27FC236}">
                 <a16:creationId xmlns:a16="http://schemas.microsoft.com/office/drawing/2014/main" id="{4EE81F27-A2FC-54A4-9BD3-2E705EEA2164}"/>
@@ -16010,6 +16426,386 @@
           </a:fontRef>
         </p:style>
       </p:cxnSp>
+      <p:sp>
+        <p:nvSpPr>
+          <p:cNvPr id="170" name="TextBox 169">
+            <a:extLst>
+              <a:ext uri="{FF2B5EF4-FFF2-40B4-BE49-F238E27FC236}">
+                <a16:creationId xmlns:a16="http://schemas.microsoft.com/office/drawing/2014/main" id="{B9DACAD8-B9E0-E96C-4ACB-CB40C5842B50}"/>
+              </a:ext>
+            </a:extLst>
+          </p:cNvPr>
+          <p:cNvSpPr txBox="1"/>
+          <p:nvPr/>
+        </p:nvSpPr>
+        <p:spPr>
+          <a:xfrm>
+            <a:off x="-74558" y="2635833"/>
+            <a:ext cx="4827531" cy="215444"/>
+          </a:xfrm>
+          <a:prstGeom prst="rect">
+            <a:avLst/>
+          </a:prstGeom>
+          <a:noFill/>
+        </p:spPr>
+        <p:txBody>
+          <a:bodyPr wrap="square" rtlCol="0">
+            <a:spAutoFit/>
+          </a:bodyPr>
+          <a:lstStyle/>
+          <a:p>
+            <a:r>
+              <a:rPr lang="en-US" sz="800" dirty="0">
+                <a:solidFill>
+                  <a:schemeClr val="tx1">
+                    <a:lumMod val="95000"/>
+                    <a:lumOff val="5000"/>
+                  </a:schemeClr>
+                </a:solidFill>
+                <a:latin typeface="Calibri Light" panose="020F0302020204030204" pitchFamily="34" charset="0"/>
+                <a:cs typeface="Calibri Light" panose="020F0302020204030204" pitchFamily="34" charset="0"/>
+              </a:rPr>
+              <a:t>(c) Practical construction of the 2x2 contingency table for each grid-box in the  considered geographical domain</a:t>
+            </a:r>
+          </a:p>
+        </p:txBody>
+      </p:sp>
+      <p:pic>
+        <p:nvPicPr>
+          <p:cNvPr id="171" name="Graphic 170">
+            <a:extLst>
+              <a:ext uri="{FF2B5EF4-FFF2-40B4-BE49-F238E27FC236}">
+                <a16:creationId xmlns:a16="http://schemas.microsoft.com/office/drawing/2014/main" id="{499574A5-DBB1-A835-3099-B6F210FD833C}"/>
+              </a:ext>
+            </a:extLst>
+          </p:cNvPr>
+          <p:cNvPicPr>
+            <a:picLocks noChangeAspect="1"/>
+          </p:cNvPicPr>
+          <p:nvPr/>
+        </p:nvPicPr>
+        <p:blipFill>
+          <a:blip r:embed="rId3">
+            <a:extLst>
+              <a:ext uri="{96DAC541-7B7A-43D3-8B79-37D633B846F1}">
+                <asvg:svgBlip xmlns:asvg="http://schemas.microsoft.com/office/drawing/2016/SVG/main" r:embed="rId4"/>
+              </a:ext>
+            </a:extLst>
+          </a:blip>
+          <a:srcRect t="22441" r="77804" b="18546"/>
+          <a:stretch>
+            <a:fillRect/>
+          </a:stretch>
+        </p:blipFill>
+        <p:spPr>
+          <a:xfrm>
+            <a:off x="143169" y="3183919"/>
+            <a:ext cx="1278402" cy="1208481"/>
+          </a:xfrm>
+          <a:prstGeom prst="rect">
+            <a:avLst/>
+          </a:prstGeom>
+        </p:spPr>
+      </p:pic>
+      <p:sp>
+        <p:nvSpPr>
+          <p:cNvPr id="172" name="TextBox 171">
+            <a:extLst>
+              <a:ext uri="{FF2B5EF4-FFF2-40B4-BE49-F238E27FC236}">
+                <a16:creationId xmlns:a16="http://schemas.microsoft.com/office/drawing/2014/main" id="{7F9A54EC-7677-98F3-A2A9-8D12ECCFFC18}"/>
+              </a:ext>
+            </a:extLst>
+          </p:cNvPr>
+          <p:cNvSpPr txBox="1"/>
+          <p:nvPr/>
+        </p:nvSpPr>
+        <p:spPr>
+          <a:xfrm>
+            <a:off x="197684" y="2897435"/>
+            <a:ext cx="1163512" cy="215444"/>
+          </a:xfrm>
+          <a:prstGeom prst="rect">
+            <a:avLst/>
+          </a:prstGeom>
+          <a:noFill/>
+        </p:spPr>
+        <p:txBody>
+          <a:bodyPr wrap="square" rtlCol="0">
+            <a:spAutoFit/>
+          </a:bodyPr>
+          <a:lstStyle/>
+          <a:p>
+            <a:pPr algn="ctr"/>
+            <a:r>
+              <a:rPr lang="en-US" sz="800" dirty="0">
+                <a:solidFill>
+                  <a:schemeClr val="tx1">
+                    <a:lumMod val="95000"/>
+                    <a:lumOff val="5000"/>
+                  </a:schemeClr>
+                </a:solidFill>
+                <a:latin typeface="Calibri Light" panose="020F0302020204030204" pitchFamily="34" charset="0"/>
+                <a:cs typeface="Calibri Light" panose="020F0302020204030204" pitchFamily="34" charset="0"/>
+              </a:rPr>
+              <a:t>Observed binary field</a:t>
+            </a:r>
+          </a:p>
+        </p:txBody>
+      </p:sp>
+      <p:sp>
+        <p:nvSpPr>
+          <p:cNvPr id="173" name="TextBox 172">
+            <a:extLst>
+              <a:ext uri="{FF2B5EF4-FFF2-40B4-BE49-F238E27FC236}">
+                <a16:creationId xmlns:a16="http://schemas.microsoft.com/office/drawing/2014/main" id="{69264F16-B69D-6B4B-97B4-69D4F6D781F7}"/>
+              </a:ext>
+            </a:extLst>
+          </p:cNvPr>
+          <p:cNvSpPr txBox="1"/>
+          <p:nvPr/>
+        </p:nvSpPr>
+        <p:spPr>
+          <a:xfrm>
+            <a:off x="1920137" y="2835880"/>
+            <a:ext cx="1897547" cy="338554"/>
+          </a:xfrm>
+          <a:prstGeom prst="rect">
+            <a:avLst/>
+          </a:prstGeom>
+          <a:noFill/>
+        </p:spPr>
+        <p:txBody>
+          <a:bodyPr wrap="square" rtlCol="0">
+            <a:spAutoFit/>
+          </a:bodyPr>
+          <a:lstStyle/>
+          <a:p>
+            <a:pPr algn="ctr"/>
+            <a:r>
+              <a:rPr lang="en-US" sz="800" dirty="0">
+                <a:solidFill>
+                  <a:schemeClr val="tx1">
+                    <a:lumMod val="95000"/>
+                    <a:lumOff val="5000"/>
+                  </a:schemeClr>
+                </a:solidFill>
+                <a:latin typeface="Calibri Light" panose="020F0302020204030204" pitchFamily="34" charset="0"/>
+                <a:cs typeface="Calibri Light" panose="020F0302020204030204" pitchFamily="34" charset="0"/>
+              </a:rPr>
+              <a:t>Predicted binary field (for a probability of exceeding the verifying rainfall threshold)</a:t>
+            </a:r>
+          </a:p>
+        </p:txBody>
+      </p:sp>
+      <p:sp>
+        <p:nvSpPr>
+          <p:cNvPr id="174" name="TextBox 173">
+            <a:extLst>
+              <a:ext uri="{FF2B5EF4-FFF2-40B4-BE49-F238E27FC236}">
+                <a16:creationId xmlns:a16="http://schemas.microsoft.com/office/drawing/2014/main" id="{7B459E9B-BC54-D128-00BB-242594E7828F}"/>
+              </a:ext>
+            </a:extLst>
+          </p:cNvPr>
+          <p:cNvSpPr txBox="1"/>
+          <p:nvPr/>
+        </p:nvSpPr>
+        <p:spPr>
+          <a:xfrm>
+            <a:off x="4280793" y="2846673"/>
+            <a:ext cx="1412962" cy="338554"/>
+          </a:xfrm>
+          <a:prstGeom prst="rect">
+            <a:avLst/>
+          </a:prstGeom>
+          <a:noFill/>
+        </p:spPr>
+        <p:txBody>
+          <a:bodyPr wrap="square" rtlCol="0">
+            <a:spAutoFit/>
+          </a:bodyPr>
+          <a:lstStyle/>
+          <a:p>
+            <a:pPr algn="ctr"/>
+            <a:r>
+              <a:rPr lang="en-US" sz="800" dirty="0">
+                <a:solidFill>
+                  <a:schemeClr val="tx1">
+                    <a:lumMod val="95000"/>
+                    <a:lumOff val="5000"/>
+                  </a:schemeClr>
+                </a:solidFill>
+                <a:latin typeface="Calibri Light" panose="020F0302020204030204" pitchFamily="34" charset="0"/>
+                <a:cs typeface="Calibri Light" panose="020F0302020204030204" pitchFamily="34" charset="0"/>
+              </a:rPr>
+              <a:t>Values of the 2x2 contingency table in each grid-box</a:t>
+            </a:r>
+          </a:p>
+        </p:txBody>
+      </p:sp>
+      <p:pic>
+        <p:nvPicPr>
+          <p:cNvPr id="175" name="Graphic 174">
+            <a:extLst>
+              <a:ext uri="{FF2B5EF4-FFF2-40B4-BE49-F238E27FC236}">
+                <a16:creationId xmlns:a16="http://schemas.microsoft.com/office/drawing/2014/main" id="{33171DA4-F999-1BCA-6CDC-E62EB7A0D3A4}"/>
+              </a:ext>
+            </a:extLst>
+          </p:cNvPr>
+          <p:cNvPicPr>
+            <a:picLocks noChangeAspect="1"/>
+          </p:cNvPicPr>
+          <p:nvPr/>
+        </p:nvPicPr>
+        <p:blipFill>
+          <a:blip r:embed="rId3">
+            <a:extLst>
+              <a:ext uri="{96DAC541-7B7A-43D3-8B79-37D633B846F1}">
+                <asvg:svgBlip xmlns:asvg="http://schemas.microsoft.com/office/drawing/2016/SVG/main" r:embed="rId4"/>
+              </a:ext>
+            </a:extLst>
+          </a:blip>
+          <a:srcRect l="60328" t="22441" r="17475" b="18546"/>
+          <a:stretch>
+            <a:fillRect/>
+          </a:stretch>
+        </p:blipFill>
+        <p:spPr>
+          <a:xfrm>
+            <a:off x="4357838" y="3183919"/>
+            <a:ext cx="1278402" cy="1208481"/>
+          </a:xfrm>
+          <a:prstGeom prst="rect">
+            <a:avLst/>
+          </a:prstGeom>
+        </p:spPr>
+      </p:pic>
+      <p:pic>
+        <p:nvPicPr>
+          <p:cNvPr id="176" name="Graphic 175">
+            <a:extLst>
+              <a:ext uri="{FF2B5EF4-FFF2-40B4-BE49-F238E27FC236}">
+                <a16:creationId xmlns:a16="http://schemas.microsoft.com/office/drawing/2014/main" id="{631A71EA-6234-2CC1-4520-6B28E47168AD}"/>
+              </a:ext>
+            </a:extLst>
+          </p:cNvPr>
+          <p:cNvPicPr>
+            <a:picLocks noChangeAspect="1"/>
+          </p:cNvPicPr>
+          <p:nvPr/>
+        </p:nvPicPr>
+        <p:blipFill>
+          <a:blip r:embed="rId3">
+            <a:extLst>
+              <a:ext uri="{96DAC541-7B7A-43D3-8B79-37D633B846F1}">
+                <asvg:svgBlip xmlns:asvg="http://schemas.microsoft.com/office/drawing/2016/SVG/main" r:embed="rId4"/>
+              </a:ext>
+            </a:extLst>
+          </a:blip>
+          <a:srcRect l="28404" t="22441" r="49814" b="18546"/>
+          <a:stretch>
+            <a:fillRect/>
+          </a:stretch>
+        </p:blipFill>
+        <p:spPr>
+          <a:xfrm>
+            <a:off x="2262447" y="3183919"/>
+            <a:ext cx="1254515" cy="1208481"/>
+          </a:xfrm>
+          <a:prstGeom prst="rect">
+            <a:avLst/>
+          </a:prstGeom>
+        </p:spPr>
+      </p:pic>
+      <p:sp>
+        <p:nvSpPr>
+          <p:cNvPr id="177" name="TextBox 176">
+            <a:extLst>
+              <a:ext uri="{FF2B5EF4-FFF2-40B4-BE49-F238E27FC236}">
+                <a16:creationId xmlns:a16="http://schemas.microsoft.com/office/drawing/2014/main" id="{1398DA6C-3D5E-DD45-9EEB-E8E386580228}"/>
+              </a:ext>
+            </a:extLst>
+          </p:cNvPr>
+          <p:cNvSpPr txBox="1"/>
+          <p:nvPr/>
+        </p:nvSpPr>
+        <p:spPr>
+          <a:xfrm>
+            <a:off x="1245892" y="3680437"/>
+            <a:ext cx="1163512" cy="215444"/>
+          </a:xfrm>
+          <a:prstGeom prst="rect">
+            <a:avLst/>
+          </a:prstGeom>
+          <a:noFill/>
+        </p:spPr>
+        <p:txBody>
+          <a:bodyPr wrap="square" rtlCol="0">
+            <a:spAutoFit/>
+          </a:bodyPr>
+          <a:lstStyle/>
+          <a:p>
+            <a:pPr algn="ctr"/>
+            <a:r>
+              <a:rPr lang="en-US" sz="800" dirty="0">
+                <a:solidFill>
+                  <a:schemeClr val="tx1">
+                    <a:lumMod val="95000"/>
+                    <a:lumOff val="5000"/>
+                  </a:schemeClr>
+                </a:solidFill>
+                <a:latin typeface="Calibri Light" panose="020F0302020204030204" pitchFamily="34" charset="0"/>
+                <a:cs typeface="Calibri Light" panose="020F0302020204030204" pitchFamily="34" charset="0"/>
+              </a:rPr>
+              <a:t>overlapped with</a:t>
+            </a:r>
+          </a:p>
+        </p:txBody>
+      </p:sp>
+      <p:sp>
+        <p:nvSpPr>
+          <p:cNvPr id="178" name="TextBox 177">
+            <a:extLst>
+              <a:ext uri="{FF2B5EF4-FFF2-40B4-BE49-F238E27FC236}">
+                <a16:creationId xmlns:a16="http://schemas.microsoft.com/office/drawing/2014/main" id="{8E734807-A9EC-31E5-F187-A3C719CDF111}"/>
+              </a:ext>
+            </a:extLst>
+          </p:cNvPr>
+          <p:cNvSpPr txBox="1"/>
+          <p:nvPr/>
+        </p:nvSpPr>
+        <p:spPr>
+          <a:xfrm>
+            <a:off x="3320846" y="3680437"/>
+            <a:ext cx="1163512" cy="215444"/>
+          </a:xfrm>
+          <a:prstGeom prst="rect">
+            <a:avLst/>
+          </a:prstGeom>
+          <a:noFill/>
+        </p:spPr>
+        <p:txBody>
+          <a:bodyPr wrap="square" rtlCol="0">
+            <a:spAutoFit/>
+          </a:bodyPr>
+          <a:lstStyle/>
+          <a:p>
+            <a:pPr algn="ctr"/>
+            <a:r>
+              <a:rPr lang="en-US" sz="800" dirty="0">
+                <a:solidFill>
+                  <a:schemeClr val="tx1">
+                    <a:lumMod val="95000"/>
+                    <a:lumOff val="5000"/>
+                  </a:schemeClr>
+                </a:solidFill>
+                <a:latin typeface="Calibri Light" panose="020F0302020204030204" pitchFamily="34" charset="0"/>
+                <a:cs typeface="Calibri Light" panose="020F0302020204030204" pitchFamily="34" charset="0"/>
+              </a:rPr>
+              <a:t>=</a:t>
+            </a:r>
+          </a:p>
+        </p:txBody>
+      </p:sp>
     </p:spTree>
     <p:extLst>
       <p:ext uri="{BB962C8B-B14F-4D97-AF65-F5344CB8AC3E}">

</xml_diff>